<commit_message>
Pitch deck: ten interviews on the evidence slide
The interview slide now lists the ten companies (sorted by size) with a
notes column, 9/10 and 10/10 findings and a per-company dot row; the
problem slide, segment criteria, GTM, closing slide and speaker notes
use the updated figures and wording.

Co-Authored-By: Claude Opus 5.5 <noreply@anthropic.com>
Claude-Session: https://claude.ai/code/session_014caquVusosa3kVCh1zkBu4
</commit_message>
<xml_diff>
--- a/docs/pitch/FinBridge_teqdimat.pptx
+++ b/docs/pitch/FinBridge_teqdimat.pptx
@@ -119,44 +119,44 @@
   <p:extLst>
     <p:ext uri="{521415D9-36F7-43E2-AB2F-B90AF26B5E84}">
       <p14:sectionLst xmlns:p14="http://schemas.microsoft.com/office/powerpoint/2010/main">
-        <p14:section name="Giriş" id="{2e08ba68-9f92-11fe-5e13-026e35822d4d}">
+        <p14:section name="Giriş" id="{d5acbd51-8039-ed8f-94ac-9b055fe7dc12}">
           <p14:sldIdLst>
             <p14:sldId id="256"/>
           </p14:sldIdLst>
         </p14:section>
-        <p14:section name="Problem" id="{875c6acb-faaa-928a-a63b-7af263b8c168}">
+        <p14:section name="Problem" id="{b449c961-9f58-ec9f-fea6-75005045f651}">
           <p14:sldIdLst>
             <p14:sldId id="257"/>
             <p14:sldId id="258"/>
           </p14:sldIdLst>
         </p14:section>
-        <p14:section name="Müştəri seqmenti" id="{bcd40f4b-d0a9-82bf-816b-40904ca962ae}">
+        <p14:section name="Müştəri seqmenti" id="{3261e223-541b-8e47-210b-d0bf546d4f14}">
           <p14:sldIdLst>
             <p14:sldId id="259"/>
           </p14:sldIdLst>
         </p14:section>
-        <p14:section name="Həll" id="{18610b84-53ba-d239-5373-aac9fa0ac9cb}">
+        <p14:section name="Həll" id="{b434ea7c-e14d-3c45-cded-f898894d8b94}">
           <p14:sldIdLst>
             <p14:sldId id="260"/>
           </p14:sldIdLst>
         </p14:section>
-        <p14:section name="MVP" id="{648961d4-39db-4a9f-f586-fd2ef3dda0e8}">
+        <p14:section name="MVP" id="{53edcfe6-c083-8aec-05f9-4846e6e1e124}">
           <p14:sldIdLst>
             <p14:sldId id="261"/>
             <p14:sldId id="262"/>
           </p14:sldIdLst>
         </p14:section>
-        <p14:section name="GTM" id="{beb30c6b-2a59-0c52-500e-ce1736c69a86}">
+        <p14:section name="GTM" id="{a453b78e-1a57-89e9-4e19-342fa7734fb2}">
           <p14:sldIdLst>
             <p14:sldId id="263"/>
           </p14:sldIdLst>
         </p14:section>
-        <p14:section name="Yekun" id="{fca17454-3ee7-9fef-b611-06adad77b802}">
+        <p14:section name="Yekun" id="{e64863f3-30b0-d7a4-3fa2-ca660a162ae0}">
           <p14:sldIdLst>
             <p14:sldId id="264"/>
           </p14:sldIdLst>
         </p14:section>
-        <p14:section name="Əlavə (suallar üçün)" id="{9a77cc6c-6faf-2d4c-8b36-c9b98af4f66c}">
+        <p14:section name="Əlavə (suallar üçün)" id="{03aaa92c-bedb-018f-a1c2-75c71ff3b612}">
           <p14:sldIdLst>
             <p14:sldId id="265"/>
             <p14:sldId id="266"/>
@@ -1008,7 +1008,7 @@
           <a:p>
             <a:r>
               <a:rPr lang="en-US" dirty="0"/>
-              <a:t>(~18 san.) Danışdığımız şirkətlərdə mənzərə belədir: büdcə ya sistemli planlanmır, ya da hər departament öz Excel faylını hazırlayır. Maliyyə komandası bu faylları əl ilə birləşdirir, versiyalar qarışır, hesablamalarda səhv olur — və il ərzində büdcəni izləmək çətinləşir.</a:t>
+              <a:t>(~18 san.) Danışdığımız şirkətlərdə mənzərə belədir: büdcə ya sistemli planlanmır, ya da hər departament öz Excel faylını hazırlayır. Maliyyə komandası bu faylları əl ilə birləşdirir — məlumat itkisi riski artır, versiyalar qarışır, hesablamalarda səhv olur və il ərzində büdcəni izləmək çətinləşir.</a:t>
             </a:r>
             <a:endParaRPr lang="en-US" dirty="0"/>
           </a:p>
@@ -1096,7 +1096,7 @@
           <a:p>
             <a:r>
               <a:rPr lang="en-US" dirty="0"/>
-              <a:t>(~25 san.) Bunu altı müsahibədə gördük. Beş şirkət büdcəni Excel ilə aparır — PASHA Bank-da Excel və VBA ilə. ŞamFi müntəzəm planlamanın yetərsiz olduğunu dedi. Azersun Holding-də ERP var, amma büdcə prosesini tam əhatə etmir. Bu, problem kəşfidir: nəticələr yalnız bu altı şirkətə aiddir, ödəməyə hazırlığı isə ayrıca yoxlayacağıq.</a:t>
+              <a:t>(~25 san.) Bunu on şirkətlə müsahibədə yoxladıq; aralarında banklar və holdinq var. Doqquz şirkət büdcəni Excel ilə aparır — PASHA Bank və ABB-də Excel və VBA ilə. ŞamFi müntəzəm planlamanın yetərsiz olduğunu dedi, Azersun Holding-də isə ERP büdcə prosesini tam əhatə etmir. Bu, problem kəşfidir: nəticələr yalnız bu on şirkətə aiddir, ödəməyə hazırlığı isə ayrıca yoxlayacağıq.</a:t>
             </a:r>
             <a:endParaRPr lang="en-US" dirty="0"/>
           </a:p>
@@ -1536,7 +1536,7 @@
           <a:p>
             <a:r>
               <a:rPr lang="en-US" dirty="0"/>
-              <a:t>(~28 san.) İlk müştərilərə yolumuz: LinkedIn-də CFO və büdcə sahiblərinə müraciət, üz-üzə görüş və canlı demo, şirkətin öz strukturu ilə test mühiti, sonra pilot və ödəməyə hazırlığın yoxlanılması. İlk dəvətlər müsahibə etdiyimiz altı şirkətə gedəcək — hələ heç biri ilə pilot razılaşması yoxdur. Növbəti real imkan 2027 büdcə dövrüdür. Uğuru demo qəbulundan ödəməyə hazırlığa qədər bu altı göstərici ilə ölçəcəyik.</a:t>
+              <a:t>(~28 san.) İlk müştərilərə yolumuz: LinkedIn-də CFO və büdcə sahiblərinə müraciət, üz-üzə görüş və canlı demo, şirkətin öz strukturu ilə test mühiti, sonra pilot və ödəməyə hazırlığın yoxlanılması. İlk dəvətlər müsahibə etdiyimiz on şirkətə gedəcək — hələ heç biri ilə pilot razılaşması yoxdur. Növbəti real imkan 2027 büdcə dövrüdür. Uğuru demo qəbulundan ödəməyə hazırlığa qədər bu altı göstərici ilə ölçəcəyik.</a:t>
             </a:r>
             <a:endParaRPr lang="en-US" dirty="0"/>
           </a:p>
@@ -2820,7 +2820,7 @@
       </p:grpSpPr>
       <p:sp>
         <p:nvSpPr>
-          <p:cNvPr id="2" name="kicker-237"/>
+          <p:cNvPr id="2" name="kicker-268"/>
           <p:cNvSpPr txBox="1"/>
           <p:nvPr/>
         </p:nvSpPr>
@@ -2900,7 +2900,7 @@
       </p:sp>
       <p:sp>
         <p:nvSpPr>
-          <p:cNvPr id="4" name="shot-frame-238"/>
+          <p:cNvPr id="4" name="shot-frame-269"/>
           <p:cNvSpPr/>
           <p:nvPr/>
         </p:nvSpPr>
@@ -2929,7 +2929,7 @@
       </p:sp>
       <p:pic>
         <p:nvPicPr>
-          <p:cNvPr id="5" name="screenshot-239" descr="Planlama cədvəli: 2025 büdcə və fakt, 2026 ilkin və yekun büdcə, 9 ay fakt və proqnoz, 2027 plan və fərqlər">    </p:cNvPr>
+          <p:cNvPr id="5" name="screenshot-270" descr="Planlama cədvəli: 2025 büdcə və fakt, 2026 ilkin və yekun büdcə, 9 ay fakt və proqnoz, 2027 plan və fərqlər">    </p:cNvPr>
           <p:cNvPicPr>
             <a:picLocks noChangeAspect="1"/>
           </p:cNvPicPr>
@@ -2953,7 +2953,7 @@
       </p:pic>
       <p:sp>
         <p:nvSpPr>
-          <p:cNvPr id="6" name="chip-240"/>
+          <p:cNvPr id="6" name="chip-271"/>
           <p:cNvSpPr/>
           <p:nvPr/>
         </p:nvSpPr>
@@ -2977,7 +2977,7 @@
       </p:sp>
       <p:sp>
         <p:nvSpPr>
-          <p:cNvPr id="7" name="chip-text-241"/>
+          <p:cNvPr id="7" name="chip-text-272"/>
           <p:cNvSpPr txBox="1"/>
           <p:nvPr/>
         </p:nvSpPr>
@@ -3016,7 +3016,7 @@
       </p:sp>
       <p:sp>
         <p:nvSpPr>
-          <p:cNvPr id="8" name="text-242"/>
+          <p:cNvPr id="8" name="text-273"/>
           <p:cNvSpPr txBox="1"/>
           <p:nvPr/>
         </p:nvSpPr>
@@ -3128,7 +3128,7 @@
       </p:grpSpPr>
       <p:sp>
         <p:nvSpPr>
-          <p:cNvPr id="2" name="kicker-243"/>
+          <p:cNvPr id="2" name="kicker-274"/>
           <p:cNvSpPr txBox="1"/>
           <p:nvPr/>
         </p:nvSpPr>
@@ -3208,7 +3208,7 @@
       </p:sp>
       <p:sp>
         <p:nvSpPr>
-          <p:cNvPr id="4" name="text-244"/>
+          <p:cNvPr id="4" name="text-275"/>
           <p:cNvSpPr txBox="1"/>
           <p:nvPr/>
         </p:nvSpPr>
@@ -3247,7 +3247,7 @@
       </p:sp>
       <p:sp>
         <p:nvSpPr>
-          <p:cNvPr id="5" name="text-245"/>
+          <p:cNvPr id="5" name="text-276"/>
           <p:cNvSpPr txBox="1"/>
           <p:nvPr/>
         </p:nvSpPr>
@@ -3286,7 +3286,7 @@
       </p:sp>
       <p:sp>
         <p:nvSpPr>
-          <p:cNvPr id="6" name="shot-frame-246"/>
+          <p:cNvPr id="6" name="shot-frame-277"/>
           <p:cNvSpPr/>
           <p:nvPr/>
         </p:nvSpPr>
@@ -3315,7 +3315,7 @@
       </p:sp>
       <p:pic>
         <p:nvPicPr>
-          <p:cNvPr id="7" name="screenshot-247" descr="Sorğunun təsdiq axını: mərhələlər, statuslar, gecikmə, CFO üçün təlimat">    </p:cNvPr>
+          <p:cNvPr id="7" name="screenshot-278" descr="Sorğunun təsdiq axını: mərhələlər, statuslar, gecikmə, CFO üçün təlimat">    </p:cNvPr>
           <p:cNvPicPr>
             <a:picLocks noChangeAspect="1"/>
           </p:cNvPicPr>
@@ -3339,7 +3339,7 @@
       </p:pic>
       <p:sp>
         <p:nvSpPr>
-          <p:cNvPr id="8" name="text-248"/>
+          <p:cNvPr id="8" name="text-279"/>
           <p:cNvSpPr txBox="1"/>
           <p:nvPr/>
         </p:nvSpPr>
@@ -3378,7 +3378,7 @@
       </p:sp>
       <p:sp>
         <p:nvSpPr>
-          <p:cNvPr id="9" name="text-249"/>
+          <p:cNvPr id="9" name="text-280"/>
           <p:cNvSpPr txBox="1"/>
           <p:nvPr/>
         </p:nvSpPr>
@@ -3417,7 +3417,7 @@
       </p:sp>
       <p:sp>
         <p:nvSpPr>
-          <p:cNvPr id="10" name="shot-frame-250"/>
+          <p:cNvPr id="10" name="shot-frame-281"/>
           <p:cNvSpPr/>
           <p:nvPr/>
         </p:nvSpPr>
@@ -3446,7 +3446,7 @@
       </p:sp>
       <p:pic>
         <p:nvPicPr>
-          <p:cNvPr id="11" name="screenshot-251" descr="Təsdiq mərhələsinin davranışı: komitə rejimi, qaytarma, şərh və təlimat">    </p:cNvPr>
+          <p:cNvPr id="11" name="screenshot-282" descr="Təsdiq mərhələsinin davranışı: komitə rejimi, qaytarma, şərh və təlimat">    </p:cNvPr>
           <p:cNvPicPr>
             <a:picLocks noChangeAspect="1"/>
           </p:cNvPicPr>
@@ -3470,7 +3470,7 @@
       </p:pic>
       <p:sp>
         <p:nvSpPr>
-          <p:cNvPr id="12" name="chip-252"/>
+          <p:cNvPr id="12" name="chip-283"/>
           <p:cNvSpPr/>
           <p:nvPr/>
         </p:nvSpPr>
@@ -3494,7 +3494,7 @@
       </p:sp>
       <p:sp>
         <p:nvSpPr>
-          <p:cNvPr id="13" name="chip-text-253"/>
+          <p:cNvPr id="13" name="chip-text-284"/>
           <p:cNvSpPr txBox="1"/>
           <p:nvPr/>
         </p:nvSpPr>
@@ -3606,7 +3606,7 @@
       </p:grpSpPr>
       <p:sp>
         <p:nvSpPr>
-          <p:cNvPr id="2" name="kicker-254"/>
+          <p:cNvPr id="2" name="kicker-285"/>
           <p:cNvSpPr txBox="1"/>
           <p:nvPr/>
         </p:nvSpPr>
@@ -3686,7 +3686,7 @@
       </p:sp>
       <p:sp>
         <p:nvSpPr>
-          <p:cNvPr id="4" name="text-255"/>
+          <p:cNvPr id="4" name="text-286"/>
           <p:cNvSpPr txBox="1"/>
           <p:nvPr/>
         </p:nvSpPr>
@@ -3725,7 +3725,7 @@
       </p:sp>
       <p:sp>
         <p:nvSpPr>
-          <p:cNvPr id="5" name="shot-frame-256"/>
+          <p:cNvPr id="5" name="shot-frame-287"/>
           <p:cNvSpPr/>
           <p:nvPr/>
         </p:nvSpPr>
@@ -3754,7 +3754,7 @@
       </p:sp>
       <p:pic>
         <p:nvPicPr>
-          <p:cNvPr id="6" name="screenshot-257" descr="Təşkilati struktur — ağac görünüşü">    </p:cNvPr>
+          <p:cNvPr id="6" name="screenshot-288" descr="Təşkilati struktur — ağac görünüşü">    </p:cNvPr>
           <p:cNvPicPr>
             <a:picLocks noChangeAspect="1"/>
           </p:cNvPicPr>
@@ -3778,7 +3778,7 @@
       </p:pic>
       <p:sp>
         <p:nvSpPr>
-          <p:cNvPr id="7" name="text-258"/>
+          <p:cNvPr id="7" name="text-289"/>
           <p:cNvSpPr txBox="1"/>
           <p:nvPr/>
         </p:nvSpPr>
@@ -3817,7 +3817,7 @@
       </p:sp>
       <p:sp>
         <p:nvSpPr>
-          <p:cNvPr id="8" name="shot-frame-259"/>
+          <p:cNvPr id="8" name="shot-frame-290"/>
           <p:cNvSpPr/>
           <p:nvPr/>
         </p:nvSpPr>
@@ -3846,7 +3846,7 @@
       </p:sp>
       <p:pic>
         <p:nvPicPr>
-          <p:cNvPr id="9" name="screenshot-260" descr="Rollar: səhifə icazələri və məlumat görünürlüyü">    </p:cNvPr>
+          <p:cNvPr id="9" name="screenshot-291" descr="Rollar: səhifə icazələri və məlumat görünürlüyü">    </p:cNvPr>
           <p:cNvPicPr>
             <a:picLocks noChangeAspect="1"/>
           </p:cNvPicPr>
@@ -3870,7 +3870,7 @@
       </p:pic>
       <p:sp>
         <p:nvSpPr>
-          <p:cNvPr id="10" name="chip-261"/>
+          <p:cNvPr id="10" name="chip-292"/>
           <p:cNvSpPr/>
           <p:nvPr/>
         </p:nvSpPr>
@@ -3894,7 +3894,7 @@
       </p:sp>
       <p:sp>
         <p:nvSpPr>
-          <p:cNvPr id="11" name="chip-text-262"/>
+          <p:cNvPr id="11" name="chip-text-293"/>
           <p:cNvSpPr txBox="1"/>
           <p:nvPr/>
         </p:nvSpPr>
@@ -3933,7 +3933,7 @@
       </p:sp>
       <p:sp>
         <p:nvSpPr>
-          <p:cNvPr id="12" name="chip-263"/>
+          <p:cNvPr id="12" name="chip-294"/>
           <p:cNvSpPr/>
           <p:nvPr/>
         </p:nvSpPr>
@@ -3957,7 +3957,7 @@
       </p:sp>
       <p:sp>
         <p:nvSpPr>
-          <p:cNvPr id="13" name="chip-text-264"/>
+          <p:cNvPr id="13" name="chip-text-295"/>
           <p:cNvSpPr txBox="1"/>
           <p:nvPr/>
         </p:nvSpPr>
@@ -3996,7 +3996,7 @@
       </p:sp>
       <p:sp>
         <p:nvSpPr>
-          <p:cNvPr id="14" name="chip-265"/>
+          <p:cNvPr id="14" name="chip-296"/>
           <p:cNvSpPr/>
           <p:nvPr/>
         </p:nvSpPr>
@@ -4020,7 +4020,7 @@
       </p:sp>
       <p:sp>
         <p:nvSpPr>
-          <p:cNvPr id="15" name="chip-text-266"/>
+          <p:cNvPr id="15" name="chip-text-297"/>
           <p:cNvSpPr txBox="1"/>
           <p:nvPr/>
         </p:nvSpPr>
@@ -4059,7 +4059,7 @@
       </p:sp>
       <p:sp>
         <p:nvSpPr>
-          <p:cNvPr id="16" name="chip-267"/>
+          <p:cNvPr id="16" name="chip-298"/>
           <p:cNvSpPr/>
           <p:nvPr/>
         </p:nvSpPr>
@@ -4083,7 +4083,7 @@
       </p:sp>
       <p:sp>
         <p:nvSpPr>
-          <p:cNvPr id="17" name="chip-text-268"/>
+          <p:cNvPr id="17" name="chip-text-299"/>
           <p:cNvSpPr txBox="1"/>
           <p:nvPr/>
         </p:nvSpPr>
@@ -4122,7 +4122,7 @@
       </p:sp>
       <p:sp>
         <p:nvSpPr>
-          <p:cNvPr id="18" name="chip-269"/>
+          <p:cNvPr id="18" name="chip-300"/>
           <p:cNvSpPr/>
           <p:nvPr/>
         </p:nvSpPr>
@@ -4146,7 +4146,7 @@
       </p:sp>
       <p:sp>
         <p:nvSpPr>
-          <p:cNvPr id="19" name="chip-text-270"/>
+          <p:cNvPr id="19" name="chip-text-301"/>
           <p:cNvSpPr txBox="1"/>
           <p:nvPr/>
         </p:nvSpPr>
@@ -4185,7 +4185,7 @@
       </p:sp>
       <p:sp>
         <p:nvSpPr>
-          <p:cNvPr id="20" name="chip-271"/>
+          <p:cNvPr id="20" name="chip-302"/>
           <p:cNvSpPr/>
           <p:nvPr/>
         </p:nvSpPr>
@@ -4209,7 +4209,7 @@
       </p:sp>
       <p:sp>
         <p:nvSpPr>
-          <p:cNvPr id="21" name="chip-text-272"/>
+          <p:cNvPr id="21" name="chip-text-303"/>
           <p:cNvSpPr txBox="1"/>
           <p:nvPr/>
         </p:nvSpPr>
@@ -4248,7 +4248,7 @@
       </p:sp>
       <p:sp>
         <p:nvSpPr>
-          <p:cNvPr id="22" name="chip-273"/>
+          <p:cNvPr id="22" name="chip-304"/>
           <p:cNvSpPr/>
           <p:nvPr/>
         </p:nvSpPr>
@@ -4272,7 +4272,7 @@
       </p:sp>
       <p:sp>
         <p:nvSpPr>
-          <p:cNvPr id="23" name="chip-text-274"/>
+          <p:cNvPr id="23" name="chip-text-305"/>
           <p:cNvSpPr txBox="1"/>
           <p:nvPr/>
         </p:nvSpPr>
@@ -4384,7 +4384,7 @@
       </p:grpSpPr>
       <p:sp>
         <p:nvSpPr>
-          <p:cNvPr id="2" name="kicker-275"/>
+          <p:cNvPr id="2" name="kicker-306"/>
           <p:cNvSpPr txBox="1"/>
           <p:nvPr/>
         </p:nvSpPr>
@@ -5525,7 +5525,7 @@
       </p:graphicFrame>
       <p:sp>
         <p:nvSpPr>
-          <p:cNvPr id="5" name="text-276"/>
+          <p:cNvPr id="5" name="text-307"/>
           <p:cNvSpPr txBox="1"/>
           <p:nvPr/>
         </p:nvSpPr>
@@ -5760,8 +5760,8 @@
         </p:blipFill>
         <p:spPr>
           <a:xfrm>
-            <a:off x="777240" y="1481328"/>
-            <a:ext cx="530352" cy="530352"/>
+            <a:off x="777240" y="1444752"/>
+            <a:ext cx="493776" cy="493776"/>
           </a:xfrm>
           <a:prstGeom prst="rect">
             <a:avLst/>
@@ -5776,8 +5776,8 @@
         </p:nvSpPr>
         <p:spPr>
           <a:xfrm>
-            <a:off x="777240" y="2194560"/>
-            <a:ext cx="3154680" cy="1417320"/>
+            <a:off x="777240" y="2103120"/>
+            <a:ext cx="3200400" cy="1691640"/>
           </a:xfrm>
           <a:prstGeom prst="rect">
             <a:avLst/>
@@ -5791,12 +5791,12 @@
           <a:p>
             <a:pPr algn="l" indent="0" marL="0">
               <a:lnSpc>
-                <a:spcPct val="110000"/>
-              </a:lnSpc>
-              <a:buNone/>
-            </a:pPr>
-            <a:r>
-              <a:rPr lang="en-US" sz="2100" b="1" dirty="0">
+                <a:spcPct val="108000"/>
+              </a:lnSpc>
+              <a:buNone/>
+            </a:pPr>
+            <a:r>
+              <a:rPr lang="en-US" sz="1900" b="1" dirty="0">
                 <a:solidFill>
                   <a:schemeClr val="bg1"/>
                 </a:solidFill>
@@ -5804,9 +5804,9 @@
                 <a:ea typeface="Cambria" pitchFamily="34" charset="-122"/>
                 <a:cs typeface="Cambria" pitchFamily="34" charset="-120"/>
               </a:rPr>
-              <a:t>Büdcə ya sistemli planlanmır, ya da hər departamentin ayrı Excel faylında hazırlanır.</a:t>
-            </a:r>
-            <a:endParaRPr lang="en-US" sz="2100" dirty="0"/>
+              <a:t>Büdcə planlaması ya sistemli şəkildə aparılmır, ya da hər departament büdcəsini ayrı-ayrı Excel fayllarında hazırlayır.</a:t>
+            </a:r>
+            <a:endParaRPr lang="en-US" sz="1900" dirty="0"/>
           </a:p>
         </p:txBody>
       </p:sp>
@@ -5818,8 +5818,8 @@
         </p:nvSpPr>
         <p:spPr>
           <a:xfrm>
-            <a:off x="777240" y="3886200"/>
-            <a:ext cx="3154680" cy="457200"/>
+            <a:off x="777240" y="4005072"/>
+            <a:ext cx="3154680" cy="411480"/>
           </a:xfrm>
           <a:prstGeom prst="rect">
             <a:avLst/>
@@ -5858,11 +5858,11 @@
         <p:spPr>
           <a:xfrm>
             <a:off x="4480560" y="1188720"/>
-            <a:ext cx="4206240" cy="1051560"/>
+            <a:ext cx="4206240" cy="1243584"/>
           </a:xfrm>
           <a:prstGeom prst="roundRect">
             <a:avLst>
-              <a:gd name="adj" fmla="val 8696"/>
+              <a:gd name="adj" fmla="val 7353"/>
             </a:avLst>
           </a:prstGeom>
           <a:solidFill>
@@ -5886,7 +5886,7 @@
         </p:nvSpPr>
         <p:spPr>
           <a:xfrm>
-            <a:off x="4709160" y="1435608"/>
+            <a:off x="4709160" y="1527048"/>
             <a:ext cx="566928" cy="566928"/>
           </a:xfrm>
           <a:prstGeom prst="ellipse">
@@ -5916,7 +5916,7 @@
         </p:blipFill>
         <p:spPr>
           <a:xfrm>
-            <a:off x="4845223" y="1571671"/>
+            <a:off x="4845223" y="1663111"/>
             <a:ext cx="294803" cy="294803"/>
           </a:xfrm>
           <a:prstGeom prst="rect">
@@ -5932,8 +5932,47 @@
         </p:nvSpPr>
         <p:spPr>
           <a:xfrm>
-            <a:off x="5486400" y="1389888"/>
-            <a:ext cx="3063240" cy="292608"/>
+            <a:off x="5486400" y="1364742"/>
+            <a:ext cx="3090672" cy="274320"/>
+          </a:xfrm>
+          <a:prstGeom prst="rect">
+            <a:avLst/>
+          </a:prstGeom>
+          <a:noFill/>
+          <a:ln/>
+        </p:spPr>
+        <p:txBody>
+          <a:bodyPr wrap="square" lIns="0" tIns="0" rIns="0" bIns="0" rtlCol="0" anchor="ctr"/>
+          <a:lstStyle/>
+          <a:p>
+            <a:pPr algn="l" indent="0" marL="0">
+              <a:lnSpc>
+                <a:spcPct val="105000"/>
+              </a:lnSpc>
+              <a:buNone/>
+            </a:pPr>
+            <a:r>
+              <a:rPr lang="en-US" sz="1600" b="1" dirty="0">
+                <a:solidFill>
+                  <a:schemeClr val="tx1"/>
+                </a:solidFill>
+              </a:rPr>
+              <a:t>Konsolidasiya çətindir</a:t>
+            </a:r>
+            <a:endParaRPr lang="en-US" sz="1600" dirty="0"/>
+          </a:p>
+        </p:txBody>
+      </p:sp>
+      <p:sp>
+        <p:nvSpPr>
+          <p:cNvPr id="12" name="text-15"/>
+          <p:cNvSpPr txBox="1"/>
+          <p:nvPr/>
+        </p:nvSpPr>
+        <p:spPr>
+          <a:xfrm>
+            <a:off x="5486400" y="1693926"/>
+            <a:ext cx="3090672" cy="580644"/>
           </a:xfrm>
           <a:prstGeom prst="rect">
             <a:avLst/>
@@ -5952,53 +5991,14 @@
               <a:buNone/>
             </a:pPr>
             <a:r>
-              <a:rPr lang="en-US" sz="1600" b="1" dirty="0">
-                <a:solidFill>
-                  <a:schemeClr val="tx1"/>
-                </a:solidFill>
-              </a:rPr>
-              <a:t>Konsolidasiya çətindir</a:t>
-            </a:r>
-            <a:endParaRPr lang="en-US" sz="1600" dirty="0"/>
-          </a:p>
-        </p:txBody>
-      </p:sp>
-      <p:sp>
-        <p:nvSpPr>
-          <p:cNvPr id="12" name="text-15"/>
-          <p:cNvSpPr txBox="1"/>
-          <p:nvPr/>
-        </p:nvSpPr>
-        <p:spPr>
-          <a:xfrm>
-            <a:off x="5486400" y="1709928"/>
-            <a:ext cx="3063240" cy="365760"/>
-          </a:xfrm>
-          <a:prstGeom prst="rect">
-            <a:avLst/>
-          </a:prstGeom>
-          <a:noFill/>
-          <a:ln/>
-        </p:spPr>
-        <p:txBody>
-          <a:bodyPr wrap="square" lIns="0" tIns="0" rIns="0" bIns="0" rtlCol="0" anchor="t"/>
-          <a:lstStyle/>
-          <a:p>
-            <a:pPr algn="l" indent="0" marL="0">
-              <a:lnSpc>
-                <a:spcPct val="105000"/>
-              </a:lnSpc>
-              <a:buNone/>
-            </a:pPr>
-            <a:r>
-              <a:rPr lang="en-US" sz="1250" dirty="0">
+              <a:rPr lang="en-US" sz="1200" dirty="0">
                 <a:solidFill>
                   <a:schemeClr val="tx2"/>
                 </a:solidFill>
               </a:rPr>
-              <a:t>Departament faylları əl ilə birləşdirilir</a:t>
-            </a:r>
-            <a:endParaRPr lang="en-US" sz="1250" dirty="0"/>
+              <a:t>Departamentlərin büdcə faylları əl ilə birləşdirilir. Manual proseslər məlumatların itirilməsi və ya səhvən silinməsi riskini artırır.</a:t>
+            </a:r>
+            <a:endParaRPr lang="en-US" sz="1200" dirty="0"/>
           </a:p>
         </p:txBody>
       </p:sp>
@@ -6010,12 +6010,12 @@
         </p:nvSpPr>
         <p:spPr>
           <a:xfrm>
-            <a:off x="4480560" y="2377440"/>
-            <a:ext cx="4206240" cy="1051560"/>
+            <a:off x="4480560" y="2523744"/>
+            <a:ext cx="4206240" cy="996696"/>
           </a:xfrm>
           <a:prstGeom prst="roundRect">
             <a:avLst>
-              <a:gd name="adj" fmla="val 8696"/>
+              <a:gd name="adj" fmla="val 9174"/>
             </a:avLst>
           </a:prstGeom>
           <a:solidFill>
@@ -6039,7 +6039,7 @@
         </p:nvSpPr>
         <p:spPr>
           <a:xfrm>
-            <a:off x="4709160" y="2624328"/>
+            <a:off x="4709160" y="2738628"/>
             <a:ext cx="566928" cy="566928"/>
           </a:xfrm>
           <a:prstGeom prst="ellipse">
@@ -6069,7 +6069,7 @@
         </p:blipFill>
         <p:spPr>
           <a:xfrm>
-            <a:off x="4845223" y="2760391"/>
+            <a:off x="4845223" y="2874691"/>
             <a:ext cx="294803" cy="294803"/>
           </a:xfrm>
           <a:prstGeom prst="rect">
@@ -6085,8 +6085,47 @@
         </p:nvSpPr>
         <p:spPr>
           <a:xfrm>
-            <a:off x="5486400" y="2578608"/>
-            <a:ext cx="3063240" cy="292608"/>
+            <a:off x="5486400" y="2763774"/>
+            <a:ext cx="3090672" cy="274320"/>
+          </a:xfrm>
+          <a:prstGeom prst="rect">
+            <a:avLst/>
+          </a:prstGeom>
+          <a:noFill/>
+          <a:ln/>
+        </p:spPr>
+        <p:txBody>
+          <a:bodyPr wrap="square" lIns="0" tIns="0" rIns="0" bIns="0" rtlCol="0" anchor="ctr"/>
+          <a:lstStyle/>
+          <a:p>
+            <a:pPr algn="l" indent="0" marL="0">
+              <a:lnSpc>
+                <a:spcPct val="105000"/>
+              </a:lnSpc>
+              <a:buNone/>
+            </a:pPr>
+            <a:r>
+              <a:rPr lang="en-US" sz="1600" b="1" dirty="0">
+                <a:solidFill>
+                  <a:schemeClr val="tx1"/>
+                </a:solidFill>
+              </a:rPr>
+              <a:t>Hesablama və versiya səhvləri</a:t>
+            </a:r>
+            <a:endParaRPr lang="en-US" sz="1600" dirty="0"/>
+          </a:p>
+        </p:txBody>
+      </p:sp>
+      <p:sp>
+        <p:nvSpPr>
+          <p:cNvPr id="17" name="text-20"/>
+          <p:cNvSpPr txBox="1"/>
+          <p:nvPr/>
+        </p:nvSpPr>
+        <p:spPr>
+          <a:xfrm>
+            <a:off x="5486400" y="3092958"/>
+            <a:ext cx="3090672" cy="205740"/>
           </a:xfrm>
           <a:prstGeom prst="rect">
             <a:avLst/>
@@ -6105,53 +6144,14 @@
               <a:buNone/>
             </a:pPr>
             <a:r>
-              <a:rPr lang="en-US" sz="1600" b="1" dirty="0">
-                <a:solidFill>
-                  <a:schemeClr val="tx1"/>
-                </a:solidFill>
-              </a:rPr>
-              <a:t>Hesablama və versiya səhvləri</a:t>
-            </a:r>
-            <a:endParaRPr lang="en-US" sz="1600" dirty="0"/>
-          </a:p>
-        </p:txBody>
-      </p:sp>
-      <p:sp>
-        <p:nvSpPr>
-          <p:cNvPr id="17" name="text-20"/>
-          <p:cNvSpPr txBox="1"/>
-          <p:nvPr/>
-        </p:nvSpPr>
-        <p:spPr>
-          <a:xfrm>
-            <a:off x="5486400" y="2898648"/>
-            <a:ext cx="3063240" cy="365760"/>
-          </a:xfrm>
-          <a:prstGeom prst="rect">
-            <a:avLst/>
-          </a:prstGeom>
-          <a:noFill/>
-          <a:ln/>
-        </p:spPr>
-        <p:txBody>
-          <a:bodyPr wrap="square" lIns="0" tIns="0" rIns="0" bIns="0" rtlCol="0" anchor="t"/>
-          <a:lstStyle/>
-          <a:p>
-            <a:pPr algn="l" indent="0" marL="0">
-              <a:lnSpc>
-                <a:spcPct val="105000"/>
-              </a:lnSpc>
-              <a:buNone/>
-            </a:pPr>
-            <a:r>
-              <a:rPr lang="en-US" sz="1250" dirty="0">
+              <a:rPr lang="en-US" sz="1200" dirty="0">
                 <a:solidFill>
                   <a:schemeClr val="tx2"/>
                 </a:solidFill>
               </a:rPr>
               <a:t>Hansı fayl son versiyadır — aydın olmur</a:t>
             </a:r>
-            <a:endParaRPr lang="en-US" sz="1250" dirty="0"/>
+            <a:endParaRPr lang="en-US" sz="1200" dirty="0"/>
           </a:p>
         </p:txBody>
       </p:sp>
@@ -6163,12 +6163,12 @@
         </p:nvSpPr>
         <p:spPr>
           <a:xfrm>
-            <a:off x="4480560" y="3566160"/>
-            <a:ext cx="4206240" cy="1051560"/>
+            <a:off x="4480560" y="3611880"/>
+            <a:ext cx="4206240" cy="996696"/>
           </a:xfrm>
           <a:prstGeom prst="roundRect">
             <a:avLst>
-              <a:gd name="adj" fmla="val 8696"/>
+              <a:gd name="adj" fmla="val 9174"/>
             </a:avLst>
           </a:prstGeom>
           <a:solidFill>
@@ -6192,7 +6192,7 @@
         </p:nvSpPr>
         <p:spPr>
           <a:xfrm>
-            <a:off x="4709160" y="3813048"/>
+            <a:off x="4709160" y="3826764"/>
             <a:ext cx="566928" cy="566928"/>
           </a:xfrm>
           <a:prstGeom prst="ellipse">
@@ -6222,7 +6222,7 @@
         </p:blipFill>
         <p:spPr>
           <a:xfrm>
-            <a:off x="4845223" y="3949111"/>
+            <a:off x="4845223" y="3962827"/>
             <a:ext cx="294803" cy="294803"/>
           </a:xfrm>
           <a:prstGeom prst="rect">
@@ -6238,8 +6238,47 @@
         </p:nvSpPr>
         <p:spPr>
           <a:xfrm>
-            <a:off x="5486400" y="3767328"/>
-            <a:ext cx="3063240" cy="292608"/>
+            <a:off x="5486400" y="3851910"/>
+            <a:ext cx="3090672" cy="274320"/>
+          </a:xfrm>
+          <a:prstGeom prst="rect">
+            <a:avLst/>
+          </a:prstGeom>
+          <a:noFill/>
+          <a:ln/>
+        </p:spPr>
+        <p:txBody>
+          <a:bodyPr wrap="square" lIns="0" tIns="0" rIns="0" bIns="0" rtlCol="0" anchor="ctr"/>
+          <a:lstStyle/>
+          <a:p>
+            <a:pPr algn="l" indent="0" marL="0">
+              <a:lnSpc>
+                <a:spcPct val="105000"/>
+              </a:lnSpc>
+              <a:buNone/>
+            </a:pPr>
+            <a:r>
+              <a:rPr lang="en-US" sz="1600" b="1" dirty="0">
+                <a:solidFill>
+                  <a:schemeClr val="tx1"/>
+                </a:solidFill>
+              </a:rPr>
+              <a:t>İl ərzində izləmək çətindir</a:t>
+            </a:r>
+            <a:endParaRPr lang="en-US" sz="1600" dirty="0"/>
+          </a:p>
+        </p:txBody>
+      </p:sp>
+      <p:sp>
+        <p:nvSpPr>
+          <p:cNvPr id="22" name="text-25"/>
+          <p:cNvSpPr txBox="1"/>
+          <p:nvPr/>
+        </p:nvSpPr>
+        <p:spPr>
+          <a:xfrm>
+            <a:off x="5486400" y="4181094"/>
+            <a:ext cx="3090672" cy="205740"/>
           </a:xfrm>
           <a:prstGeom prst="rect">
             <a:avLst/>
@@ -6258,53 +6297,14 @@
               <a:buNone/>
             </a:pPr>
             <a:r>
-              <a:rPr lang="en-US" sz="1600" b="1" dirty="0">
-                <a:solidFill>
-                  <a:schemeClr val="tx1"/>
-                </a:solidFill>
-              </a:rPr>
-              <a:t>İl ərzində izləmək çətindir</a:t>
-            </a:r>
-            <a:endParaRPr lang="en-US" sz="1600" dirty="0"/>
-          </a:p>
-        </p:txBody>
-      </p:sp>
-      <p:sp>
-        <p:nvSpPr>
-          <p:cNvPr id="22" name="text-25"/>
-          <p:cNvSpPr txBox="1"/>
-          <p:nvPr/>
-        </p:nvSpPr>
-        <p:spPr>
-          <a:xfrm>
-            <a:off x="5486400" y="4087368"/>
-            <a:ext cx="3063240" cy="365760"/>
-          </a:xfrm>
-          <a:prstGeom prst="rect">
-            <a:avLst/>
-          </a:prstGeom>
-          <a:noFill/>
-          <a:ln/>
-        </p:spPr>
-        <p:txBody>
-          <a:bodyPr wrap="square" lIns="0" tIns="0" rIns="0" bIns="0" rtlCol="0" anchor="t"/>
-          <a:lstStyle/>
-          <a:p>
-            <a:pPr algn="l" indent="0" marL="0">
-              <a:lnSpc>
-                <a:spcPct val="105000"/>
-              </a:lnSpc>
-              <a:buNone/>
-            </a:pPr>
-            <a:r>
-              <a:rPr lang="en-US" sz="1250" dirty="0">
+              <a:rPr lang="en-US" sz="1200" dirty="0">
                 <a:solidFill>
                   <a:schemeClr val="tx2"/>
                 </a:solidFill>
               </a:rPr>
               <a:t>Xərclər büdcə ilə vaxtında müqayisə olunmur</a:t>
             </a:r>
-            <a:endParaRPr lang="en-US" sz="1250" dirty="0"/>
+            <a:endParaRPr lang="en-US" sz="1200" dirty="0"/>
           </a:p>
         </p:txBody>
       </p:sp>
@@ -6341,7 +6341,7 @@
                   <a:schemeClr val="accent4"/>
                 </a:solidFill>
               </a:rPr>
-              <a:t>Mənbə: komandanın 6 şirkətlə apardığı problem kəşfi müsahibələri</a:t>
+              <a:t>Mənbə: komandanın 10 şirkətlə apardığı problem kəşfi müsahibələri</a:t>
             </a:r>
             <a:endParaRPr lang="en-US" sz="1000" dirty="0"/>
           </a:p>
@@ -6494,7 +6494,7 @@
                 <a:ea typeface="Cambria" pitchFamily="34" charset="-122"/>
                 <a:cs typeface="Cambria" pitchFamily="34" charset="-120"/>
               </a:rPr>
-              <a:t>Müsahibələr: 6 şirkətdə eyni boşluq</a:t>
+              <a:t>Müsahibələr: 10 şirkətdə eyni boşluq</a:t>
             </a:r>
             <a:endParaRPr lang="en-US" sz="2700" dirty="0"/>
           </a:p>
@@ -6509,11 +6509,11 @@
         <p:spPr>
           <a:xfrm>
             <a:off x="457200" y="1188720"/>
-            <a:ext cx="5257800" cy="3474720"/>
+            <a:ext cx="5440680" cy="3493008"/>
           </a:xfrm>
           <a:prstGeom prst="roundRect">
             <a:avLst>
-              <a:gd name="adj" fmla="val 2632"/>
+              <a:gd name="adj" fmla="val 2618"/>
             </a:avLst>
           </a:prstGeom>
           <a:solidFill>
@@ -6537,8 +6537,8 @@
         </p:nvSpPr>
         <p:spPr>
           <a:xfrm>
-            <a:off x="731520" y="1371600"/>
-            <a:ext cx="1828800" cy="201168"/>
+            <a:off x="685800" y="1316736"/>
+            <a:ext cx="1554480" cy="201168"/>
           </a:xfrm>
           <a:prstGeom prst="rect">
             <a:avLst/>
@@ -6576,8 +6576,8 @@
         </p:nvSpPr>
         <p:spPr>
           <a:xfrm>
-            <a:off x="2606040" y="1371600"/>
-            <a:ext cx="1097280" cy="201168"/>
+            <a:off x="2331720" y="1316736"/>
+            <a:ext cx="868680" cy="201168"/>
           </a:xfrm>
           <a:prstGeom prst="rect">
             <a:avLst/>
@@ -6615,8 +6615,8 @@
         </p:nvSpPr>
         <p:spPr>
           <a:xfrm>
-            <a:off x="3794760" y="1371600"/>
-            <a:ext cx="1645920" cy="201168"/>
+            <a:off x="3246120" y="1316736"/>
+            <a:ext cx="1234440" cy="201168"/>
           </a:xfrm>
           <a:prstGeom prst="rect">
             <a:avLst/>
@@ -6648,14 +6648,53 @@
       </p:sp>
       <p:sp>
         <p:nvSpPr>
-          <p:cNvPr id="8" name="row-line-32"/>
+          <p:cNvPr id="8" name="text-32"/>
+          <p:cNvSpPr txBox="1"/>
+          <p:nvPr/>
+        </p:nvSpPr>
+        <p:spPr>
+          <a:xfrm>
+            <a:off x="4572000" y="1316736"/>
+            <a:ext cx="1188720" cy="201168"/>
+          </a:xfrm>
+          <a:prstGeom prst="rect">
+            <a:avLst/>
+          </a:prstGeom>
+          <a:noFill/>
+          <a:ln/>
+        </p:spPr>
+        <p:txBody>
+          <a:bodyPr wrap="square" lIns="0" tIns="0" rIns="0" bIns="0" rtlCol="0" anchor="t"/>
+          <a:lstStyle/>
+          <a:p>
+            <a:pPr algn="l" indent="0" marL="0">
+              <a:lnSpc>
+                <a:spcPct val="105000"/>
+              </a:lnSpc>
+              <a:buNone/>
+            </a:pPr>
+            <a:r>
+              <a:rPr lang="en-US" sz="1000" b="1" spc="100" kern="0" dirty="0">
+                <a:solidFill>
+                  <a:schemeClr val="accent4"/>
+                </a:solidFill>
+              </a:rPr>
+              <a:t>QEYD</a:t>
+            </a:r>
+            <a:endParaRPr lang="en-US" sz="1000" dirty="0"/>
+          </a:p>
+        </p:txBody>
+      </p:sp>
+      <p:sp>
+        <p:nvSpPr>
+          <p:cNvPr id="9" name="row-line-33"/>
           <p:cNvSpPr/>
           <p:nvPr/>
         </p:nvSpPr>
         <p:spPr>
           <a:xfrm>
-            <a:off x="731520" y="1591056"/>
-            <a:ext cx="4709160" cy="0"/>
+            <a:off x="685800" y="1623060"/>
+            <a:ext cx="5029200" cy="0"/>
           </a:xfrm>
           <a:prstGeom prst="line">
             <a:avLst/>
@@ -6671,14 +6710,14 @@
       </p:sp>
       <p:sp>
         <p:nvSpPr>
-          <p:cNvPr id="9" name="text-33"/>
-          <p:cNvSpPr txBox="1"/>
-          <p:nvPr/>
-        </p:nvSpPr>
-        <p:spPr>
-          <a:xfrm>
-            <a:off x="731520" y="1655064"/>
-            <a:ext cx="1828800" cy="256032"/>
+          <p:cNvPr id="10" name="text-34"/>
+          <p:cNvSpPr txBox="1"/>
+          <p:nvPr/>
+        </p:nvSpPr>
+        <p:spPr>
+          <a:xfrm>
+            <a:off x="685800" y="1645920"/>
+            <a:ext cx="1600200" cy="256032"/>
           </a:xfrm>
           <a:prstGeom prst="rect">
             <a:avLst/>
@@ -6697,27 +6736,27 @@
               <a:buNone/>
             </a:pPr>
             <a:r>
-              <a:rPr lang="en-US" sz="1400" b="1" dirty="0">
+              <a:rPr lang="en-US" sz="1250" b="1" dirty="0">
                 <a:solidFill>
                   <a:schemeClr val="tx1"/>
                 </a:solidFill>
               </a:rPr>
-              <a:t>Milla Dairy</a:t>
-            </a:r>
-            <a:endParaRPr lang="en-US" sz="1400" dirty="0"/>
-          </a:p>
-        </p:txBody>
-      </p:sp>
-      <p:sp>
-        <p:nvSpPr>
-          <p:cNvPr id="10" name="text-34"/>
-          <p:cNvSpPr txBox="1"/>
-          <p:nvPr/>
-        </p:nvSpPr>
-        <p:spPr>
-          <a:xfrm>
-            <a:off x="2606040" y="1655064"/>
-            <a:ext cx="1143000" cy="256032"/>
+              <a:t>ABB</a:t>
+            </a:r>
+            <a:endParaRPr lang="en-US" sz="1250" dirty="0"/>
+          </a:p>
+        </p:txBody>
+      </p:sp>
+      <p:sp>
+        <p:nvSpPr>
+          <p:cNvPr id="11" name="text-35"/>
+          <p:cNvSpPr txBox="1"/>
+          <p:nvPr/>
+        </p:nvSpPr>
+        <p:spPr>
+          <a:xfrm>
+            <a:off x="2331720" y="1645920"/>
+            <a:ext cx="868680" cy="256032"/>
           </a:xfrm>
           <a:prstGeom prst="rect">
             <a:avLst/>
@@ -6736,27 +6775,27 @@
               <a:buNone/>
             </a:pPr>
             <a:r>
-              <a:rPr lang="en-US" sz="1250" dirty="0">
+              <a:rPr lang="en-US" sz="1150" dirty="0">
                 <a:solidFill>
                   <a:schemeClr val="tx2"/>
                 </a:solidFill>
               </a:rPr>
-              <a:t>1 300+ işçi</a:t>
-            </a:r>
-            <a:endParaRPr lang="en-US" sz="1250" dirty="0"/>
-          </a:p>
-        </p:txBody>
-      </p:sp>
-      <p:sp>
-        <p:nvSpPr>
-          <p:cNvPr id="11" name="chip-35"/>
+              <a:t>4 000+ işçi</a:t>
+            </a:r>
+            <a:endParaRPr lang="en-US" sz="1150" dirty="0"/>
+          </a:p>
+        </p:txBody>
+      </p:sp>
+      <p:sp>
+        <p:nvSpPr>
+          <p:cNvPr id="12" name="chip-36"/>
           <p:cNvSpPr/>
           <p:nvPr/>
         </p:nvSpPr>
         <p:spPr>
           <a:xfrm>
-            <a:off x="3794760" y="1645920"/>
-            <a:ext cx="1645920" cy="274320"/>
+            <a:off x="3246120" y="1664208"/>
+            <a:ext cx="1188720" cy="219456"/>
           </a:xfrm>
           <a:prstGeom prst="roundRect">
             <a:avLst>
@@ -6773,14 +6812,14 @@
       </p:sp>
       <p:sp>
         <p:nvSpPr>
-          <p:cNvPr id="12" name="chip-text-36"/>
-          <p:cNvSpPr txBox="1"/>
-          <p:nvPr/>
-        </p:nvSpPr>
-        <p:spPr>
-          <a:xfrm>
-            <a:off x="3794760" y="1645920"/>
-            <a:ext cx="1645920" cy="274320"/>
+          <p:cNvPr id="13" name="chip-text-37"/>
+          <p:cNvSpPr txBox="1"/>
+          <p:nvPr/>
+        </p:nvSpPr>
+        <p:spPr>
+          <a:xfrm>
+            <a:off x="3246120" y="1664208"/>
+            <a:ext cx="1188720" cy="219456"/>
           </a:xfrm>
           <a:prstGeom prst="rect">
             <a:avLst/>
@@ -6799,27 +6838,27 @@
               <a:buNone/>
             </a:pPr>
             <a:r>
-              <a:rPr lang="en-US" sz="1100" b="1" dirty="0">
+              <a:rPr lang="en-US" sz="1000" b="1" dirty="0">
                 <a:solidFill>
                   <a:schemeClr val="accent3"/>
                 </a:solidFill>
               </a:rPr>
-              <a:t>Excel</a:t>
-            </a:r>
-            <a:endParaRPr lang="en-US" sz="1100" dirty="0"/>
-          </a:p>
-        </p:txBody>
-      </p:sp>
-      <p:sp>
-        <p:nvSpPr>
-          <p:cNvPr id="13" name="row-line-37"/>
+              <a:t>Excel + VBA</a:t>
+            </a:r>
+            <a:endParaRPr lang="en-US" sz="1000" dirty="0"/>
+          </a:p>
+        </p:txBody>
+      </p:sp>
+      <p:sp>
+        <p:nvSpPr>
+          <p:cNvPr id="14" name="row-line-38"/>
           <p:cNvSpPr/>
           <p:nvPr/>
         </p:nvSpPr>
         <p:spPr>
           <a:xfrm>
-            <a:off x="731520" y="2084832"/>
-            <a:ext cx="4709160" cy="0"/>
+            <a:off x="685800" y="1920240"/>
+            <a:ext cx="5029200" cy="0"/>
           </a:xfrm>
           <a:prstGeom prst="line">
             <a:avLst/>
@@ -6835,14 +6874,14 @@
       </p:sp>
       <p:sp>
         <p:nvSpPr>
-          <p:cNvPr id="14" name="text-38"/>
-          <p:cNvSpPr txBox="1"/>
-          <p:nvPr/>
-        </p:nvSpPr>
-        <p:spPr>
-          <a:xfrm>
-            <a:off x="731520" y="2148840"/>
-            <a:ext cx="1828800" cy="256032"/>
+          <p:cNvPr id="15" name="text-39"/>
+          <p:cNvSpPr txBox="1"/>
+          <p:nvPr/>
+        </p:nvSpPr>
+        <p:spPr>
+          <a:xfrm>
+            <a:off x="685800" y="1943100"/>
+            <a:ext cx="1600200" cy="256032"/>
           </a:xfrm>
           <a:prstGeom prst="rect">
             <a:avLst/>
@@ -6861,27 +6900,27 @@
               <a:buNone/>
             </a:pPr>
             <a:r>
-              <a:rPr lang="en-US" sz="1400" b="1" dirty="0">
+              <a:rPr lang="en-US" sz="1250" b="1" dirty="0">
                 <a:solidFill>
                   <a:schemeClr val="tx1"/>
                 </a:solidFill>
               </a:rPr>
-              <a:t>Mars Overseas</a:t>
-            </a:r>
-            <a:endParaRPr lang="en-US" sz="1400" dirty="0"/>
-          </a:p>
-        </p:txBody>
-      </p:sp>
-      <p:sp>
-        <p:nvSpPr>
-          <p:cNvPr id="15" name="text-39"/>
-          <p:cNvSpPr txBox="1"/>
-          <p:nvPr/>
-        </p:nvSpPr>
-        <p:spPr>
-          <a:xfrm>
-            <a:off x="2606040" y="2148840"/>
-            <a:ext cx="1143000" cy="256032"/>
+              <a:t>Unibank</a:t>
+            </a:r>
+            <a:endParaRPr lang="en-US" sz="1250" dirty="0"/>
+          </a:p>
+        </p:txBody>
+      </p:sp>
+      <p:sp>
+        <p:nvSpPr>
+          <p:cNvPr id="16" name="text-40"/>
+          <p:cNvSpPr txBox="1"/>
+          <p:nvPr/>
+        </p:nvSpPr>
+        <p:spPr>
+          <a:xfrm>
+            <a:off x="2331720" y="1943100"/>
+            <a:ext cx="868680" cy="256032"/>
           </a:xfrm>
           <a:prstGeom prst="rect">
             <a:avLst/>
@@ -6900,27 +6939,27 @@
               <a:buNone/>
             </a:pPr>
             <a:r>
-              <a:rPr lang="en-US" sz="1250" dirty="0">
+              <a:rPr lang="en-US" sz="1150" dirty="0">
                 <a:solidFill>
                   <a:schemeClr val="tx2"/>
                 </a:solidFill>
               </a:rPr>
-              <a:t>1 200+ işçi</a:t>
-            </a:r>
-            <a:endParaRPr lang="en-US" sz="1250" dirty="0"/>
-          </a:p>
-        </p:txBody>
-      </p:sp>
-      <p:sp>
-        <p:nvSpPr>
-          <p:cNvPr id="16" name="chip-40"/>
+              <a:t>2 000+ işçi</a:t>
+            </a:r>
+            <a:endParaRPr lang="en-US" sz="1150" dirty="0"/>
+          </a:p>
+        </p:txBody>
+      </p:sp>
+      <p:sp>
+        <p:nvSpPr>
+          <p:cNvPr id="17" name="chip-41"/>
           <p:cNvSpPr/>
           <p:nvPr/>
         </p:nvSpPr>
         <p:spPr>
           <a:xfrm>
-            <a:off x="3794760" y="2139696"/>
-            <a:ext cx="1645920" cy="274320"/>
+            <a:off x="3246120" y="1961388"/>
+            <a:ext cx="1188720" cy="219456"/>
           </a:xfrm>
           <a:prstGeom prst="roundRect">
             <a:avLst>
@@ -6937,14 +6976,14 @@
       </p:sp>
       <p:sp>
         <p:nvSpPr>
-          <p:cNvPr id="17" name="chip-text-41"/>
-          <p:cNvSpPr txBox="1"/>
-          <p:nvPr/>
-        </p:nvSpPr>
-        <p:spPr>
-          <a:xfrm>
-            <a:off x="3794760" y="2139696"/>
-            <a:ext cx="1645920" cy="274320"/>
+          <p:cNvPr id="18" name="chip-text-42"/>
+          <p:cNvSpPr txBox="1"/>
+          <p:nvPr/>
+        </p:nvSpPr>
+        <p:spPr>
+          <a:xfrm>
+            <a:off x="3246120" y="1961388"/>
+            <a:ext cx="1188720" cy="219456"/>
           </a:xfrm>
           <a:prstGeom prst="rect">
             <a:avLst/>
@@ -6963,27 +7002,27 @@
               <a:buNone/>
             </a:pPr>
             <a:r>
-              <a:rPr lang="en-US" sz="1100" b="1" dirty="0">
+              <a:rPr lang="en-US" sz="1000" b="1" dirty="0">
                 <a:solidFill>
                   <a:schemeClr val="accent3"/>
                 </a:solidFill>
               </a:rPr>
               <a:t>Excel</a:t>
             </a:r>
-            <a:endParaRPr lang="en-US" sz="1100" dirty="0"/>
-          </a:p>
-        </p:txBody>
-      </p:sp>
-      <p:sp>
-        <p:nvSpPr>
-          <p:cNvPr id="18" name="row-line-42"/>
+            <a:endParaRPr lang="en-US" sz="1000" dirty="0"/>
+          </a:p>
+        </p:txBody>
+      </p:sp>
+      <p:sp>
+        <p:nvSpPr>
+          <p:cNvPr id="19" name="row-line-43"/>
           <p:cNvSpPr/>
           <p:nvPr/>
         </p:nvSpPr>
         <p:spPr>
           <a:xfrm>
-            <a:off x="731520" y="2578608"/>
-            <a:ext cx="4709160" cy="0"/>
+            <a:off x="685800" y="2217420"/>
+            <a:ext cx="5029200" cy="0"/>
           </a:xfrm>
           <a:prstGeom prst="line">
             <a:avLst/>
@@ -6999,14 +7038,14 @@
       </p:sp>
       <p:sp>
         <p:nvSpPr>
-          <p:cNvPr id="19" name="text-43"/>
-          <p:cNvSpPr txBox="1"/>
-          <p:nvPr/>
-        </p:nvSpPr>
-        <p:spPr>
-          <a:xfrm>
-            <a:off x="731520" y="2642616"/>
-            <a:ext cx="1828800" cy="256032"/>
+          <p:cNvPr id="20" name="text-44"/>
+          <p:cNvSpPr txBox="1"/>
+          <p:nvPr/>
+        </p:nvSpPr>
+        <p:spPr>
+          <a:xfrm>
+            <a:off x="685800" y="2240280"/>
+            <a:ext cx="1600200" cy="256032"/>
           </a:xfrm>
           <a:prstGeom prst="rect">
             <a:avLst/>
@@ -7025,36 +7064,36 @@
               <a:buNone/>
             </a:pPr>
             <a:r>
-              <a:rPr lang="en-US" sz="1400" b="1" dirty="0">
+              <a:rPr lang="en-US" sz="1250" b="1" dirty="0">
                 <a:solidFill>
                   <a:schemeClr val="tx1"/>
                 </a:solidFill>
               </a:rPr>
-              <a:t>ŞamFi</a:t>
-            </a:r>
-            <a:endParaRPr lang="en-US" sz="1400" dirty="0"/>
-          </a:p>
-        </p:txBody>
-      </p:sp>
-      <p:sp>
-        <p:nvSpPr>
-          <p:cNvPr id="20" name="text-44"/>
-          <p:cNvSpPr txBox="1"/>
-          <p:nvPr/>
-        </p:nvSpPr>
-        <p:spPr>
-          <a:xfrm>
-            <a:off x="731520" y="2880360"/>
-            <a:ext cx="3017520" cy="164592"/>
-          </a:xfrm>
-          <a:prstGeom prst="rect">
-            <a:avLst/>
-          </a:prstGeom>
-          <a:noFill/>
-          <a:ln/>
-        </p:spPr>
-        <p:txBody>
-          <a:bodyPr wrap="square" lIns="0" tIns="0" rIns="0" bIns="0" rtlCol="0" anchor="t"/>
+              <a:t>Sinteks MMC</a:t>
+            </a:r>
+            <a:endParaRPr lang="en-US" sz="1250" dirty="0"/>
+          </a:p>
+        </p:txBody>
+      </p:sp>
+      <p:sp>
+        <p:nvSpPr>
+          <p:cNvPr id="21" name="text-45"/>
+          <p:cNvSpPr txBox="1"/>
+          <p:nvPr/>
+        </p:nvSpPr>
+        <p:spPr>
+          <a:xfrm>
+            <a:off x="2331720" y="2240280"/>
+            <a:ext cx="868680" cy="256032"/>
+          </a:xfrm>
+          <a:prstGeom prst="rect">
+            <a:avLst/>
+          </a:prstGeom>
+          <a:noFill/>
+          <a:ln/>
+        </p:spPr>
+        <p:txBody>
+          <a:bodyPr wrap="square" lIns="0" tIns="0" rIns="0" bIns="0" rtlCol="0" anchor="ctr"/>
           <a:lstStyle/>
           <a:p>
             <a:pPr algn="l" indent="0" marL="0">
@@ -7064,53 +7103,14 @@
               <a:buNone/>
             </a:pPr>
             <a:r>
-              <a:rPr lang="en-US" sz="950" i="1" dirty="0">
-                <a:solidFill>
-                  <a:schemeClr val="accent4"/>
-                </a:solidFill>
-              </a:rPr>
-              <a:t>müntəzəm planlama yetərsizdir</a:t>
-            </a:r>
-            <a:endParaRPr lang="en-US" sz="950" dirty="0"/>
-          </a:p>
-        </p:txBody>
-      </p:sp>
-      <p:sp>
-        <p:nvSpPr>
-          <p:cNvPr id="21" name="text-45"/>
-          <p:cNvSpPr txBox="1"/>
-          <p:nvPr/>
-        </p:nvSpPr>
-        <p:spPr>
-          <a:xfrm>
-            <a:off x="2606040" y="2642616"/>
-            <a:ext cx="1143000" cy="256032"/>
-          </a:xfrm>
-          <a:prstGeom prst="rect">
-            <a:avLst/>
-          </a:prstGeom>
-          <a:noFill/>
-          <a:ln/>
-        </p:spPr>
-        <p:txBody>
-          <a:bodyPr wrap="square" lIns="0" tIns="0" rIns="0" bIns="0" rtlCol="0" anchor="ctr"/>
-          <a:lstStyle/>
-          <a:p>
-            <a:pPr algn="l" indent="0" marL="0">
-              <a:lnSpc>
-                <a:spcPct val="105000"/>
-              </a:lnSpc>
-              <a:buNone/>
-            </a:pPr>
-            <a:r>
-              <a:rPr lang="en-US" sz="1250" dirty="0">
+              <a:rPr lang="en-US" sz="1150" dirty="0">
                 <a:solidFill>
                   <a:schemeClr val="tx2"/>
                 </a:solidFill>
               </a:rPr>
-              <a:t>1 400+ işçi</a:t>
-            </a:r>
-            <a:endParaRPr lang="en-US" sz="1250" dirty="0"/>
+              <a:t>1 500+ işçi</a:t>
+            </a:r>
+            <a:endParaRPr lang="en-US" sz="1150" dirty="0"/>
           </a:p>
         </p:txBody>
       </p:sp>
@@ -7122,8 +7122,8 @@
         </p:nvSpPr>
         <p:spPr>
           <a:xfrm>
-            <a:off x="3794760" y="2633472"/>
-            <a:ext cx="1645920" cy="274320"/>
+            <a:off x="3246120" y="2258568"/>
+            <a:ext cx="1188720" cy="219456"/>
           </a:xfrm>
           <a:prstGeom prst="roundRect">
             <a:avLst>
@@ -7146,8 +7146,8 @@
         </p:nvSpPr>
         <p:spPr>
           <a:xfrm>
-            <a:off x="3794760" y="2633472"/>
-            <a:ext cx="1645920" cy="274320"/>
+            <a:off x="3246120" y="2258568"/>
+            <a:ext cx="1188720" cy="219456"/>
           </a:xfrm>
           <a:prstGeom prst="rect">
             <a:avLst/>
@@ -7166,14 +7166,14 @@
               <a:buNone/>
             </a:pPr>
             <a:r>
-              <a:rPr lang="en-US" sz="1100" b="1" dirty="0">
+              <a:rPr lang="en-US" sz="1000" b="1" dirty="0">
                 <a:solidFill>
                   <a:schemeClr val="accent3"/>
                 </a:solidFill>
               </a:rPr>
-              <a:t>Dağınıq Excel</a:t>
-            </a:r>
-            <a:endParaRPr lang="en-US" sz="1100" dirty="0"/>
+              <a:t>Excel</a:t>
+            </a:r>
+            <a:endParaRPr lang="en-US" sz="1000" dirty="0"/>
           </a:p>
         </p:txBody>
       </p:sp>
@@ -7185,8 +7185,8 @@
         </p:nvSpPr>
         <p:spPr>
           <a:xfrm>
-            <a:off x="731520" y="3072384"/>
-            <a:ext cx="4709160" cy="0"/>
+            <a:off x="685800" y="2514600"/>
+            <a:ext cx="5029200" cy="0"/>
           </a:xfrm>
           <a:prstGeom prst="line">
             <a:avLst/>
@@ -7208,8 +7208,8 @@
         </p:nvSpPr>
         <p:spPr>
           <a:xfrm>
-            <a:off x="731520" y="3136392"/>
-            <a:ext cx="1828800" cy="256032"/>
+            <a:off x="685800" y="2537460"/>
+            <a:ext cx="1600200" cy="256032"/>
           </a:xfrm>
           <a:prstGeom prst="rect">
             <a:avLst/>
@@ -7228,14 +7228,14 @@
               <a:buNone/>
             </a:pPr>
             <a:r>
-              <a:rPr lang="en-US" sz="1400" b="1" dirty="0">
+              <a:rPr lang="en-US" sz="1250" b="1" dirty="0">
                 <a:solidFill>
                   <a:schemeClr val="tx1"/>
                 </a:solidFill>
               </a:rPr>
               <a:t>PASHA Bank</a:t>
             </a:r>
-            <a:endParaRPr lang="en-US" sz="1400" dirty="0"/>
+            <a:endParaRPr lang="en-US" sz="1250" dirty="0"/>
           </a:p>
         </p:txBody>
       </p:sp>
@@ -7247,8 +7247,8 @@
         </p:nvSpPr>
         <p:spPr>
           <a:xfrm>
-            <a:off x="2606040" y="3136392"/>
-            <a:ext cx="1143000" cy="256032"/>
+            <a:off x="2331720" y="2537460"/>
+            <a:ext cx="868680" cy="256032"/>
           </a:xfrm>
           <a:prstGeom prst="rect">
             <a:avLst/>
@@ -7267,14 +7267,14 @@
               <a:buNone/>
             </a:pPr>
             <a:r>
-              <a:rPr lang="en-US" sz="1250" dirty="0">
+              <a:rPr lang="en-US" sz="1150" dirty="0">
                 <a:solidFill>
                   <a:schemeClr val="tx2"/>
                 </a:solidFill>
               </a:rPr>
               <a:t>1 400+ işçi</a:t>
             </a:r>
-            <a:endParaRPr lang="en-US" sz="1250" dirty="0"/>
+            <a:endParaRPr lang="en-US" sz="1150" dirty="0"/>
           </a:p>
         </p:txBody>
       </p:sp>
@@ -7286,8 +7286,8 @@
         </p:nvSpPr>
         <p:spPr>
           <a:xfrm>
-            <a:off x="3794760" y="3127248"/>
-            <a:ext cx="1645920" cy="274320"/>
+            <a:off x="3246120" y="2555748"/>
+            <a:ext cx="1188720" cy="219456"/>
           </a:xfrm>
           <a:prstGeom prst="roundRect">
             <a:avLst>
@@ -7310,8 +7310,8 @@
         </p:nvSpPr>
         <p:spPr>
           <a:xfrm>
-            <a:off x="3794760" y="3127248"/>
-            <a:ext cx="1645920" cy="274320"/>
+            <a:off x="3246120" y="2555748"/>
+            <a:ext cx="1188720" cy="219456"/>
           </a:xfrm>
           <a:prstGeom prst="rect">
             <a:avLst/>
@@ -7330,14 +7330,14 @@
               <a:buNone/>
             </a:pPr>
             <a:r>
-              <a:rPr lang="en-US" sz="1100" b="1" dirty="0">
+              <a:rPr lang="en-US" sz="1000" b="1" dirty="0">
                 <a:solidFill>
                   <a:schemeClr val="accent3"/>
                 </a:solidFill>
               </a:rPr>
               <a:t>Excel + VBA</a:t>
             </a:r>
-            <a:endParaRPr lang="en-US" sz="1100" dirty="0"/>
+            <a:endParaRPr lang="en-US" sz="1000" dirty="0"/>
           </a:p>
         </p:txBody>
       </p:sp>
@@ -7349,8 +7349,8 @@
         </p:nvSpPr>
         <p:spPr>
           <a:xfrm>
-            <a:off x="731520" y="3566160"/>
-            <a:ext cx="4709160" cy="0"/>
+            <a:off x="685800" y="2811780"/>
+            <a:ext cx="5029200" cy="0"/>
           </a:xfrm>
           <a:prstGeom prst="line">
             <a:avLst/>
@@ -7372,8 +7372,8 @@
         </p:nvSpPr>
         <p:spPr>
           <a:xfrm>
-            <a:off x="731520" y="3630168"/>
-            <a:ext cx="1828800" cy="256032"/>
+            <a:off x="685800" y="2834640"/>
+            <a:ext cx="1600200" cy="256032"/>
           </a:xfrm>
           <a:prstGeom prst="rect">
             <a:avLst/>
@@ -7392,14 +7392,14 @@
               <a:buNone/>
             </a:pPr>
             <a:r>
-              <a:rPr lang="en-US" sz="1400" b="1" dirty="0">
+              <a:rPr lang="en-US" sz="1250" b="1" dirty="0">
                 <a:solidFill>
                   <a:schemeClr val="tx1"/>
                 </a:solidFill>
               </a:rPr>
-              <a:t>VektorDS</a:t>
-            </a:r>
-            <a:endParaRPr lang="en-US" sz="1400" dirty="0"/>
+              <a:t>ŞamFi</a:t>
+            </a:r>
+            <a:endParaRPr lang="en-US" sz="1250" dirty="0"/>
           </a:p>
         </p:txBody>
       </p:sp>
@@ -7411,8 +7411,8 @@
         </p:nvSpPr>
         <p:spPr>
           <a:xfrm>
-            <a:off x="2606040" y="3630168"/>
-            <a:ext cx="1143000" cy="256032"/>
+            <a:off x="2331720" y="2834640"/>
+            <a:ext cx="868680" cy="256032"/>
           </a:xfrm>
           <a:prstGeom prst="rect">
             <a:avLst/>
@@ -7431,14 +7431,14 @@
               <a:buNone/>
             </a:pPr>
             <a:r>
-              <a:rPr lang="en-US" sz="1250" dirty="0">
+              <a:rPr lang="en-US" sz="1150" dirty="0">
                 <a:solidFill>
                   <a:schemeClr val="tx2"/>
                 </a:solidFill>
               </a:rPr>
-              <a:t>300+ işçi</a:t>
-            </a:r>
-            <a:endParaRPr lang="en-US" sz="1250" dirty="0"/>
+              <a:t>1 400+ işçi</a:t>
+            </a:r>
+            <a:endParaRPr lang="en-US" sz="1150" dirty="0"/>
           </a:p>
         </p:txBody>
       </p:sp>
@@ -7450,8 +7450,8 @@
         </p:nvSpPr>
         <p:spPr>
           <a:xfrm>
-            <a:off x="3794760" y="3621024"/>
-            <a:ext cx="1645920" cy="274320"/>
+            <a:off x="3246120" y="2852928"/>
+            <a:ext cx="1188720" cy="219456"/>
           </a:xfrm>
           <a:prstGeom prst="roundRect">
             <a:avLst>
@@ -7474,8 +7474,8 @@
         </p:nvSpPr>
         <p:spPr>
           <a:xfrm>
-            <a:off x="3794760" y="3621024"/>
-            <a:ext cx="1645920" cy="274320"/>
+            <a:off x="3246120" y="2852928"/>
+            <a:ext cx="1188720" cy="219456"/>
           </a:xfrm>
           <a:prstGeom prst="rect">
             <a:avLst/>
@@ -7494,27 +7494,66 @@
               <a:buNone/>
             </a:pPr>
             <a:r>
-              <a:rPr lang="en-US" sz="1100" b="1" dirty="0">
+              <a:rPr lang="en-US" sz="1000" b="1" dirty="0">
                 <a:solidFill>
                   <a:schemeClr val="accent3"/>
                 </a:solidFill>
               </a:rPr>
-              <a:t>Excel</a:t>
-            </a:r>
-            <a:endParaRPr lang="en-US" sz="1100" dirty="0"/>
-          </a:p>
-        </p:txBody>
-      </p:sp>
-      <p:sp>
-        <p:nvSpPr>
-          <p:cNvPr id="34" name="row-line-58"/>
+              <a:t>Dağınıq Excel</a:t>
+            </a:r>
+            <a:endParaRPr lang="en-US" sz="1000" dirty="0"/>
+          </a:p>
+        </p:txBody>
+      </p:sp>
+      <p:sp>
+        <p:nvSpPr>
+          <p:cNvPr id="34" name="text-58"/>
+          <p:cNvSpPr txBox="1"/>
+          <p:nvPr/>
+        </p:nvSpPr>
+        <p:spPr>
+          <a:xfrm>
+            <a:off x="4572000" y="2825496"/>
+            <a:ext cx="1261872" cy="274320"/>
+          </a:xfrm>
+          <a:prstGeom prst="rect">
+            <a:avLst/>
+          </a:prstGeom>
+          <a:noFill/>
+          <a:ln/>
+        </p:spPr>
+        <p:txBody>
+          <a:bodyPr wrap="square" lIns="0" tIns="0" rIns="0" bIns="0" rtlCol="0" anchor="ctr"/>
+          <a:lstStyle/>
+          <a:p>
+            <a:pPr algn="l" indent="0" marL="0">
+              <a:lnSpc>
+                <a:spcPct val="95000"/>
+              </a:lnSpc>
+              <a:buNone/>
+            </a:pPr>
+            <a:r>
+              <a:rPr lang="en-US" sz="900" i="1" dirty="0">
+                <a:solidFill>
+                  <a:schemeClr val="accent4"/>
+                </a:solidFill>
+              </a:rPr>
+              <a:t>müntəzəm planlama yetərsizdir</a:t>
+            </a:r>
+            <a:endParaRPr lang="en-US" sz="900" dirty="0"/>
+          </a:p>
+        </p:txBody>
+      </p:sp>
+      <p:sp>
+        <p:nvSpPr>
+          <p:cNvPr id="35" name="row-line-59"/>
           <p:cNvSpPr/>
           <p:nvPr/>
         </p:nvSpPr>
         <p:spPr>
           <a:xfrm>
-            <a:off x="731520" y="4059936"/>
-            <a:ext cx="4709160" cy="0"/>
+            <a:off x="685800" y="3108960"/>
+            <a:ext cx="5029200" cy="0"/>
           </a:xfrm>
           <a:prstGeom prst="line">
             <a:avLst/>
@@ -7530,14 +7569,14 @@
       </p:sp>
       <p:sp>
         <p:nvSpPr>
-          <p:cNvPr id="35" name="text-59"/>
-          <p:cNvSpPr txBox="1"/>
-          <p:nvPr/>
-        </p:nvSpPr>
-        <p:spPr>
-          <a:xfrm>
-            <a:off x="731520" y="4123944"/>
-            <a:ext cx="1828800" cy="256032"/>
+          <p:cNvPr id="36" name="text-60"/>
+          <p:cNvSpPr txBox="1"/>
+          <p:nvPr/>
+        </p:nvSpPr>
+        <p:spPr>
+          <a:xfrm>
+            <a:off x="685800" y="3131820"/>
+            <a:ext cx="1600200" cy="256032"/>
           </a:xfrm>
           <a:prstGeom prst="rect">
             <a:avLst/>
@@ -7556,36 +7595,36 @@
               <a:buNone/>
             </a:pPr>
             <a:r>
-              <a:rPr lang="en-US" sz="1400" b="1" dirty="0">
+              <a:rPr lang="en-US" sz="1250" b="1" dirty="0">
                 <a:solidFill>
                   <a:schemeClr val="tx1"/>
                 </a:solidFill>
               </a:rPr>
-              <a:t>Azersun Holding</a:t>
-            </a:r>
-            <a:endParaRPr lang="en-US" sz="1400" dirty="0"/>
-          </a:p>
-        </p:txBody>
-      </p:sp>
-      <p:sp>
-        <p:nvSpPr>
-          <p:cNvPr id="36" name="text-60"/>
-          <p:cNvSpPr txBox="1"/>
-          <p:nvPr/>
-        </p:nvSpPr>
-        <p:spPr>
-          <a:xfrm>
-            <a:off x="731520" y="4361688"/>
-            <a:ext cx="3017520" cy="164592"/>
-          </a:xfrm>
-          <a:prstGeom prst="rect">
-            <a:avLst/>
-          </a:prstGeom>
-          <a:noFill/>
-          <a:ln/>
-        </p:spPr>
-        <p:txBody>
-          <a:bodyPr wrap="square" lIns="0" tIns="0" rIns="0" bIns="0" rtlCol="0" anchor="t"/>
+              <a:t>Milla Dairy</a:t>
+            </a:r>
+            <a:endParaRPr lang="en-US" sz="1250" dirty="0"/>
+          </a:p>
+        </p:txBody>
+      </p:sp>
+      <p:sp>
+        <p:nvSpPr>
+          <p:cNvPr id="37" name="text-61"/>
+          <p:cNvSpPr txBox="1"/>
+          <p:nvPr/>
+        </p:nvSpPr>
+        <p:spPr>
+          <a:xfrm>
+            <a:off x="2331720" y="3131820"/>
+            <a:ext cx="868680" cy="256032"/>
+          </a:xfrm>
+          <a:prstGeom prst="rect">
+            <a:avLst/>
+          </a:prstGeom>
+          <a:noFill/>
+          <a:ln/>
+        </p:spPr>
+        <p:txBody>
+          <a:bodyPr wrap="square" lIns="0" tIns="0" rIns="0" bIns="0" rtlCol="0" anchor="ctr"/>
           <a:lstStyle/>
           <a:p>
             <a:pPr algn="l" indent="0" marL="0">
@@ -7595,53 +7634,14 @@
               <a:buNone/>
             </a:pPr>
             <a:r>
-              <a:rPr lang="en-US" sz="950" i="1" dirty="0">
-                <a:solidFill>
-                  <a:schemeClr val="accent4"/>
-                </a:solidFill>
-              </a:rPr>
-              <a:t>büdcə prosesini tam əhatə etmir</a:t>
-            </a:r>
-            <a:endParaRPr lang="en-US" sz="950" dirty="0"/>
-          </a:p>
-        </p:txBody>
-      </p:sp>
-      <p:sp>
-        <p:nvSpPr>
-          <p:cNvPr id="37" name="text-61"/>
-          <p:cNvSpPr txBox="1"/>
-          <p:nvPr/>
-        </p:nvSpPr>
-        <p:spPr>
-          <a:xfrm>
-            <a:off x="2606040" y="4123944"/>
-            <a:ext cx="1143000" cy="256032"/>
-          </a:xfrm>
-          <a:prstGeom prst="rect">
-            <a:avLst/>
-          </a:prstGeom>
-          <a:noFill/>
-          <a:ln/>
-        </p:spPr>
-        <p:txBody>
-          <a:bodyPr wrap="square" lIns="0" tIns="0" rIns="0" bIns="0" rtlCol="0" anchor="ctr"/>
-          <a:lstStyle/>
-          <a:p>
-            <a:pPr algn="l" indent="0" marL="0">
-              <a:lnSpc>
-                <a:spcPct val="105000"/>
-              </a:lnSpc>
-              <a:buNone/>
-            </a:pPr>
-            <a:r>
-              <a:rPr lang="en-US" sz="1250" dirty="0">
+              <a:rPr lang="en-US" sz="1150" dirty="0">
                 <a:solidFill>
                   <a:schemeClr val="tx2"/>
                 </a:solidFill>
               </a:rPr>
-              <a:t>Holdinq</a:t>
-            </a:r>
-            <a:endParaRPr lang="en-US" sz="1250" dirty="0"/>
+              <a:t>1 300+ işçi</a:t>
+            </a:r>
+            <a:endParaRPr lang="en-US" sz="1150" dirty="0"/>
           </a:p>
         </p:txBody>
       </p:sp>
@@ -7653,8 +7653,664 @@
         </p:nvSpPr>
         <p:spPr>
           <a:xfrm>
-            <a:off x="3794760" y="4114800"/>
-            <a:ext cx="1645920" cy="274320"/>
+            <a:off x="3246120" y="3150108"/>
+            <a:ext cx="1188720" cy="219456"/>
+          </a:xfrm>
+          <a:prstGeom prst="roundRect">
+            <a:avLst>
+              <a:gd name="adj" fmla="val 50000"/>
+            </a:avLst>
+          </a:prstGeom>
+          <a:solidFill>
+            <a:schemeClr val="accent3">
+              <a:alpha val="12000"/>
+            </a:schemeClr>
+          </a:solidFill>
+          <a:ln/>
+        </p:spPr>
+      </p:sp>
+      <p:sp>
+        <p:nvSpPr>
+          <p:cNvPr id="39" name="chip-text-63"/>
+          <p:cNvSpPr txBox="1"/>
+          <p:nvPr/>
+        </p:nvSpPr>
+        <p:spPr>
+          <a:xfrm>
+            <a:off x="3246120" y="3150108"/>
+            <a:ext cx="1188720" cy="219456"/>
+          </a:xfrm>
+          <a:prstGeom prst="rect">
+            <a:avLst/>
+          </a:prstGeom>
+          <a:noFill/>
+          <a:ln/>
+        </p:spPr>
+        <p:txBody>
+          <a:bodyPr wrap="square" lIns="0" tIns="0" rIns="0" bIns="0" rtlCol="0" anchor="ctr"/>
+          <a:lstStyle/>
+          <a:p>
+            <a:pPr algn="ctr" indent="0" marL="0">
+              <a:lnSpc>
+                <a:spcPct val="105000"/>
+              </a:lnSpc>
+              <a:buNone/>
+            </a:pPr>
+            <a:r>
+              <a:rPr lang="en-US" sz="1000" b="1" dirty="0">
+                <a:solidFill>
+                  <a:schemeClr val="accent3"/>
+                </a:solidFill>
+              </a:rPr>
+              <a:t>Excel</a:t>
+            </a:r>
+            <a:endParaRPr lang="en-US" sz="1000" dirty="0"/>
+          </a:p>
+        </p:txBody>
+      </p:sp>
+      <p:sp>
+        <p:nvSpPr>
+          <p:cNvPr id="40" name="row-line-64"/>
+          <p:cNvSpPr/>
+          <p:nvPr/>
+        </p:nvSpPr>
+        <p:spPr>
+          <a:xfrm>
+            <a:off x="685800" y="3406140"/>
+            <a:ext cx="5029200" cy="0"/>
+          </a:xfrm>
+          <a:prstGeom prst="line">
+            <a:avLst/>
+          </a:prstGeom>
+          <a:noFill/>
+          <a:ln w="9525">
+            <a:solidFill>
+              <a:schemeClr val="accent6"/>
+            </a:solidFill>
+            <a:prstDash val="solid"/>
+          </a:ln>
+        </p:spPr>
+      </p:sp>
+      <p:sp>
+        <p:nvSpPr>
+          <p:cNvPr id="41" name="text-65"/>
+          <p:cNvSpPr txBox="1"/>
+          <p:nvPr/>
+        </p:nvSpPr>
+        <p:spPr>
+          <a:xfrm>
+            <a:off x="685800" y="3429000"/>
+            <a:ext cx="1600200" cy="256032"/>
+          </a:xfrm>
+          <a:prstGeom prst="rect">
+            <a:avLst/>
+          </a:prstGeom>
+          <a:noFill/>
+          <a:ln/>
+        </p:spPr>
+        <p:txBody>
+          <a:bodyPr wrap="square" lIns="0" tIns="0" rIns="0" bIns="0" rtlCol="0" anchor="ctr"/>
+          <a:lstStyle/>
+          <a:p>
+            <a:pPr algn="l" indent="0" marL="0">
+              <a:lnSpc>
+                <a:spcPct val="105000"/>
+              </a:lnSpc>
+              <a:buNone/>
+            </a:pPr>
+            <a:r>
+              <a:rPr lang="en-US" sz="1250" b="1" dirty="0">
+                <a:solidFill>
+                  <a:schemeClr val="tx1"/>
+                </a:solidFill>
+              </a:rPr>
+              <a:t>Rabitə Bank</a:t>
+            </a:r>
+            <a:endParaRPr lang="en-US" sz="1250" dirty="0"/>
+          </a:p>
+        </p:txBody>
+      </p:sp>
+      <p:sp>
+        <p:nvSpPr>
+          <p:cNvPr id="42" name="text-66"/>
+          <p:cNvSpPr txBox="1"/>
+          <p:nvPr/>
+        </p:nvSpPr>
+        <p:spPr>
+          <a:xfrm>
+            <a:off x="2331720" y="3429000"/>
+            <a:ext cx="868680" cy="256032"/>
+          </a:xfrm>
+          <a:prstGeom prst="rect">
+            <a:avLst/>
+          </a:prstGeom>
+          <a:noFill/>
+          <a:ln/>
+        </p:spPr>
+        <p:txBody>
+          <a:bodyPr wrap="square" lIns="0" tIns="0" rIns="0" bIns="0" rtlCol="0" anchor="ctr"/>
+          <a:lstStyle/>
+          <a:p>
+            <a:pPr algn="l" indent="0" marL="0">
+              <a:lnSpc>
+                <a:spcPct val="105000"/>
+              </a:lnSpc>
+              <a:buNone/>
+            </a:pPr>
+            <a:r>
+              <a:rPr lang="en-US" sz="1150" dirty="0">
+                <a:solidFill>
+                  <a:schemeClr val="tx2"/>
+                </a:solidFill>
+              </a:rPr>
+              <a:t>1 300+ işçi</a:t>
+            </a:r>
+            <a:endParaRPr lang="en-US" sz="1150" dirty="0"/>
+          </a:p>
+        </p:txBody>
+      </p:sp>
+      <p:sp>
+        <p:nvSpPr>
+          <p:cNvPr id="43" name="chip-67"/>
+          <p:cNvSpPr/>
+          <p:nvPr/>
+        </p:nvSpPr>
+        <p:spPr>
+          <a:xfrm>
+            <a:off x="3246120" y="3447288"/>
+            <a:ext cx="1188720" cy="219456"/>
+          </a:xfrm>
+          <a:prstGeom prst="roundRect">
+            <a:avLst>
+              <a:gd name="adj" fmla="val 50000"/>
+            </a:avLst>
+          </a:prstGeom>
+          <a:solidFill>
+            <a:schemeClr val="accent3">
+              <a:alpha val="12000"/>
+            </a:schemeClr>
+          </a:solidFill>
+          <a:ln/>
+        </p:spPr>
+      </p:sp>
+      <p:sp>
+        <p:nvSpPr>
+          <p:cNvPr id="44" name="chip-text-68"/>
+          <p:cNvSpPr txBox="1"/>
+          <p:nvPr/>
+        </p:nvSpPr>
+        <p:spPr>
+          <a:xfrm>
+            <a:off x="3246120" y="3447288"/>
+            <a:ext cx="1188720" cy="219456"/>
+          </a:xfrm>
+          <a:prstGeom prst="rect">
+            <a:avLst/>
+          </a:prstGeom>
+          <a:noFill/>
+          <a:ln/>
+        </p:spPr>
+        <p:txBody>
+          <a:bodyPr wrap="square" lIns="0" tIns="0" rIns="0" bIns="0" rtlCol="0" anchor="ctr"/>
+          <a:lstStyle/>
+          <a:p>
+            <a:pPr algn="ctr" indent="0" marL="0">
+              <a:lnSpc>
+                <a:spcPct val="105000"/>
+              </a:lnSpc>
+              <a:buNone/>
+            </a:pPr>
+            <a:r>
+              <a:rPr lang="en-US" sz="1000" b="1" dirty="0">
+                <a:solidFill>
+                  <a:schemeClr val="accent3"/>
+                </a:solidFill>
+              </a:rPr>
+              <a:t>Excel</a:t>
+            </a:r>
+            <a:endParaRPr lang="en-US" sz="1000" dirty="0"/>
+          </a:p>
+        </p:txBody>
+      </p:sp>
+      <p:sp>
+        <p:nvSpPr>
+          <p:cNvPr id="45" name="row-line-69"/>
+          <p:cNvSpPr/>
+          <p:nvPr/>
+        </p:nvSpPr>
+        <p:spPr>
+          <a:xfrm>
+            <a:off x="685800" y="3703320"/>
+            <a:ext cx="5029200" cy="0"/>
+          </a:xfrm>
+          <a:prstGeom prst="line">
+            <a:avLst/>
+          </a:prstGeom>
+          <a:noFill/>
+          <a:ln w="9525">
+            <a:solidFill>
+              <a:schemeClr val="accent6"/>
+            </a:solidFill>
+            <a:prstDash val="solid"/>
+          </a:ln>
+        </p:spPr>
+      </p:sp>
+      <p:sp>
+        <p:nvSpPr>
+          <p:cNvPr id="46" name="text-70"/>
+          <p:cNvSpPr txBox="1"/>
+          <p:nvPr/>
+        </p:nvSpPr>
+        <p:spPr>
+          <a:xfrm>
+            <a:off x="685800" y="3726180"/>
+            <a:ext cx="1600200" cy="256032"/>
+          </a:xfrm>
+          <a:prstGeom prst="rect">
+            <a:avLst/>
+          </a:prstGeom>
+          <a:noFill/>
+          <a:ln/>
+        </p:spPr>
+        <p:txBody>
+          <a:bodyPr wrap="square" lIns="0" tIns="0" rIns="0" bIns="0" rtlCol="0" anchor="ctr"/>
+          <a:lstStyle/>
+          <a:p>
+            <a:pPr algn="l" indent="0" marL="0">
+              <a:lnSpc>
+                <a:spcPct val="105000"/>
+              </a:lnSpc>
+              <a:buNone/>
+            </a:pPr>
+            <a:r>
+              <a:rPr lang="en-US" sz="1250" b="1" dirty="0">
+                <a:solidFill>
+                  <a:schemeClr val="tx1"/>
+                </a:solidFill>
+              </a:rPr>
+              <a:t>Mars Overseas</a:t>
+            </a:r>
+            <a:endParaRPr lang="en-US" sz="1250" dirty="0"/>
+          </a:p>
+        </p:txBody>
+      </p:sp>
+      <p:sp>
+        <p:nvSpPr>
+          <p:cNvPr id="47" name="text-71"/>
+          <p:cNvSpPr txBox="1"/>
+          <p:nvPr/>
+        </p:nvSpPr>
+        <p:spPr>
+          <a:xfrm>
+            <a:off x="2331720" y="3726180"/>
+            <a:ext cx="868680" cy="256032"/>
+          </a:xfrm>
+          <a:prstGeom prst="rect">
+            <a:avLst/>
+          </a:prstGeom>
+          <a:noFill/>
+          <a:ln/>
+        </p:spPr>
+        <p:txBody>
+          <a:bodyPr wrap="square" lIns="0" tIns="0" rIns="0" bIns="0" rtlCol="0" anchor="ctr"/>
+          <a:lstStyle/>
+          <a:p>
+            <a:pPr algn="l" indent="0" marL="0">
+              <a:lnSpc>
+                <a:spcPct val="105000"/>
+              </a:lnSpc>
+              <a:buNone/>
+            </a:pPr>
+            <a:r>
+              <a:rPr lang="en-US" sz="1150" dirty="0">
+                <a:solidFill>
+                  <a:schemeClr val="tx2"/>
+                </a:solidFill>
+              </a:rPr>
+              <a:t>1 200+ işçi</a:t>
+            </a:r>
+            <a:endParaRPr lang="en-US" sz="1150" dirty="0"/>
+          </a:p>
+        </p:txBody>
+      </p:sp>
+      <p:sp>
+        <p:nvSpPr>
+          <p:cNvPr id="48" name="chip-72"/>
+          <p:cNvSpPr/>
+          <p:nvPr/>
+        </p:nvSpPr>
+        <p:spPr>
+          <a:xfrm>
+            <a:off x="3246120" y="3744468"/>
+            <a:ext cx="1188720" cy="219456"/>
+          </a:xfrm>
+          <a:prstGeom prst="roundRect">
+            <a:avLst>
+              <a:gd name="adj" fmla="val 50000"/>
+            </a:avLst>
+          </a:prstGeom>
+          <a:solidFill>
+            <a:schemeClr val="accent3">
+              <a:alpha val="12000"/>
+            </a:schemeClr>
+          </a:solidFill>
+          <a:ln/>
+        </p:spPr>
+      </p:sp>
+      <p:sp>
+        <p:nvSpPr>
+          <p:cNvPr id="49" name="chip-text-73"/>
+          <p:cNvSpPr txBox="1"/>
+          <p:nvPr/>
+        </p:nvSpPr>
+        <p:spPr>
+          <a:xfrm>
+            <a:off x="3246120" y="3744468"/>
+            <a:ext cx="1188720" cy="219456"/>
+          </a:xfrm>
+          <a:prstGeom prst="rect">
+            <a:avLst/>
+          </a:prstGeom>
+          <a:noFill/>
+          <a:ln/>
+        </p:spPr>
+        <p:txBody>
+          <a:bodyPr wrap="square" lIns="0" tIns="0" rIns="0" bIns="0" rtlCol="0" anchor="ctr"/>
+          <a:lstStyle/>
+          <a:p>
+            <a:pPr algn="ctr" indent="0" marL="0">
+              <a:lnSpc>
+                <a:spcPct val="105000"/>
+              </a:lnSpc>
+              <a:buNone/>
+            </a:pPr>
+            <a:r>
+              <a:rPr lang="en-US" sz="1000" b="1" dirty="0">
+                <a:solidFill>
+                  <a:schemeClr val="accent3"/>
+                </a:solidFill>
+              </a:rPr>
+              <a:t>Excel</a:t>
+            </a:r>
+            <a:endParaRPr lang="en-US" sz="1000" dirty="0"/>
+          </a:p>
+        </p:txBody>
+      </p:sp>
+      <p:sp>
+        <p:nvSpPr>
+          <p:cNvPr id="50" name="row-line-74"/>
+          <p:cNvSpPr/>
+          <p:nvPr/>
+        </p:nvSpPr>
+        <p:spPr>
+          <a:xfrm>
+            <a:off x="685800" y="4000500"/>
+            <a:ext cx="5029200" cy="0"/>
+          </a:xfrm>
+          <a:prstGeom prst="line">
+            <a:avLst/>
+          </a:prstGeom>
+          <a:noFill/>
+          <a:ln w="9525">
+            <a:solidFill>
+              <a:schemeClr val="accent6"/>
+            </a:solidFill>
+            <a:prstDash val="solid"/>
+          </a:ln>
+        </p:spPr>
+      </p:sp>
+      <p:sp>
+        <p:nvSpPr>
+          <p:cNvPr id="51" name="text-75"/>
+          <p:cNvSpPr txBox="1"/>
+          <p:nvPr/>
+        </p:nvSpPr>
+        <p:spPr>
+          <a:xfrm>
+            <a:off x="685800" y="4023360"/>
+            <a:ext cx="1600200" cy="256032"/>
+          </a:xfrm>
+          <a:prstGeom prst="rect">
+            <a:avLst/>
+          </a:prstGeom>
+          <a:noFill/>
+          <a:ln/>
+        </p:spPr>
+        <p:txBody>
+          <a:bodyPr wrap="square" lIns="0" tIns="0" rIns="0" bIns="0" rtlCol="0" anchor="ctr"/>
+          <a:lstStyle/>
+          <a:p>
+            <a:pPr algn="l" indent="0" marL="0">
+              <a:lnSpc>
+                <a:spcPct val="105000"/>
+              </a:lnSpc>
+              <a:buNone/>
+            </a:pPr>
+            <a:r>
+              <a:rPr lang="en-US" sz="1250" b="1" dirty="0">
+                <a:solidFill>
+                  <a:schemeClr val="tx1"/>
+                </a:solidFill>
+              </a:rPr>
+              <a:t>VektorDS</a:t>
+            </a:r>
+            <a:endParaRPr lang="en-US" sz="1250" dirty="0"/>
+          </a:p>
+        </p:txBody>
+      </p:sp>
+      <p:sp>
+        <p:nvSpPr>
+          <p:cNvPr id="52" name="text-76"/>
+          <p:cNvSpPr txBox="1"/>
+          <p:nvPr/>
+        </p:nvSpPr>
+        <p:spPr>
+          <a:xfrm>
+            <a:off x="2331720" y="4023360"/>
+            <a:ext cx="868680" cy="256032"/>
+          </a:xfrm>
+          <a:prstGeom prst="rect">
+            <a:avLst/>
+          </a:prstGeom>
+          <a:noFill/>
+          <a:ln/>
+        </p:spPr>
+        <p:txBody>
+          <a:bodyPr wrap="square" lIns="0" tIns="0" rIns="0" bIns="0" rtlCol="0" anchor="ctr"/>
+          <a:lstStyle/>
+          <a:p>
+            <a:pPr algn="l" indent="0" marL="0">
+              <a:lnSpc>
+                <a:spcPct val="105000"/>
+              </a:lnSpc>
+              <a:buNone/>
+            </a:pPr>
+            <a:r>
+              <a:rPr lang="en-US" sz="1150" dirty="0">
+                <a:solidFill>
+                  <a:schemeClr val="tx2"/>
+                </a:solidFill>
+              </a:rPr>
+              <a:t>300+ işçi</a:t>
+            </a:r>
+            <a:endParaRPr lang="en-US" sz="1150" dirty="0"/>
+          </a:p>
+        </p:txBody>
+      </p:sp>
+      <p:sp>
+        <p:nvSpPr>
+          <p:cNvPr id="53" name="chip-77"/>
+          <p:cNvSpPr/>
+          <p:nvPr/>
+        </p:nvSpPr>
+        <p:spPr>
+          <a:xfrm>
+            <a:off x="3246120" y="4041648"/>
+            <a:ext cx="1188720" cy="219456"/>
+          </a:xfrm>
+          <a:prstGeom prst="roundRect">
+            <a:avLst>
+              <a:gd name="adj" fmla="val 50000"/>
+            </a:avLst>
+          </a:prstGeom>
+          <a:solidFill>
+            <a:schemeClr val="accent3">
+              <a:alpha val="12000"/>
+            </a:schemeClr>
+          </a:solidFill>
+          <a:ln/>
+        </p:spPr>
+      </p:sp>
+      <p:sp>
+        <p:nvSpPr>
+          <p:cNvPr id="54" name="chip-text-78"/>
+          <p:cNvSpPr txBox="1"/>
+          <p:nvPr/>
+        </p:nvSpPr>
+        <p:spPr>
+          <a:xfrm>
+            <a:off x="3246120" y="4041648"/>
+            <a:ext cx="1188720" cy="219456"/>
+          </a:xfrm>
+          <a:prstGeom prst="rect">
+            <a:avLst/>
+          </a:prstGeom>
+          <a:noFill/>
+          <a:ln/>
+        </p:spPr>
+        <p:txBody>
+          <a:bodyPr wrap="square" lIns="0" tIns="0" rIns="0" bIns="0" rtlCol="0" anchor="ctr"/>
+          <a:lstStyle/>
+          <a:p>
+            <a:pPr algn="ctr" indent="0" marL="0">
+              <a:lnSpc>
+                <a:spcPct val="105000"/>
+              </a:lnSpc>
+              <a:buNone/>
+            </a:pPr>
+            <a:r>
+              <a:rPr lang="en-US" sz="1000" b="1" dirty="0">
+                <a:solidFill>
+                  <a:schemeClr val="accent3"/>
+                </a:solidFill>
+              </a:rPr>
+              <a:t>Excel</a:t>
+            </a:r>
+            <a:endParaRPr lang="en-US" sz="1000" dirty="0"/>
+          </a:p>
+        </p:txBody>
+      </p:sp>
+      <p:sp>
+        <p:nvSpPr>
+          <p:cNvPr id="55" name="row-line-79"/>
+          <p:cNvSpPr/>
+          <p:nvPr/>
+        </p:nvSpPr>
+        <p:spPr>
+          <a:xfrm>
+            <a:off x="685800" y="4297680"/>
+            <a:ext cx="5029200" cy="0"/>
+          </a:xfrm>
+          <a:prstGeom prst="line">
+            <a:avLst/>
+          </a:prstGeom>
+          <a:noFill/>
+          <a:ln w="9525">
+            <a:solidFill>
+              <a:schemeClr val="accent6"/>
+            </a:solidFill>
+            <a:prstDash val="solid"/>
+          </a:ln>
+        </p:spPr>
+      </p:sp>
+      <p:sp>
+        <p:nvSpPr>
+          <p:cNvPr id="56" name="text-80"/>
+          <p:cNvSpPr txBox="1"/>
+          <p:nvPr/>
+        </p:nvSpPr>
+        <p:spPr>
+          <a:xfrm>
+            <a:off x="685800" y="4320540"/>
+            <a:ext cx="1600200" cy="256032"/>
+          </a:xfrm>
+          <a:prstGeom prst="rect">
+            <a:avLst/>
+          </a:prstGeom>
+          <a:noFill/>
+          <a:ln/>
+        </p:spPr>
+        <p:txBody>
+          <a:bodyPr wrap="square" lIns="0" tIns="0" rIns="0" bIns="0" rtlCol="0" anchor="ctr"/>
+          <a:lstStyle/>
+          <a:p>
+            <a:pPr algn="l" indent="0" marL="0">
+              <a:lnSpc>
+                <a:spcPct val="105000"/>
+              </a:lnSpc>
+              <a:buNone/>
+            </a:pPr>
+            <a:r>
+              <a:rPr lang="en-US" sz="1250" b="1" dirty="0">
+                <a:solidFill>
+                  <a:schemeClr val="tx1"/>
+                </a:solidFill>
+              </a:rPr>
+              <a:t>Azersun Holding</a:t>
+            </a:r>
+            <a:endParaRPr lang="en-US" sz="1250" dirty="0"/>
+          </a:p>
+        </p:txBody>
+      </p:sp>
+      <p:sp>
+        <p:nvSpPr>
+          <p:cNvPr id="57" name="text-81"/>
+          <p:cNvSpPr txBox="1"/>
+          <p:nvPr/>
+        </p:nvSpPr>
+        <p:spPr>
+          <a:xfrm>
+            <a:off x="2331720" y="4320540"/>
+            <a:ext cx="868680" cy="256032"/>
+          </a:xfrm>
+          <a:prstGeom prst="rect">
+            <a:avLst/>
+          </a:prstGeom>
+          <a:noFill/>
+          <a:ln/>
+        </p:spPr>
+        <p:txBody>
+          <a:bodyPr wrap="square" lIns="0" tIns="0" rIns="0" bIns="0" rtlCol="0" anchor="ctr"/>
+          <a:lstStyle/>
+          <a:p>
+            <a:pPr algn="l" indent="0" marL="0">
+              <a:lnSpc>
+                <a:spcPct val="105000"/>
+              </a:lnSpc>
+              <a:buNone/>
+            </a:pPr>
+            <a:r>
+              <a:rPr lang="en-US" sz="1150" dirty="0">
+                <a:solidFill>
+                  <a:schemeClr val="tx2"/>
+                </a:solidFill>
+              </a:rPr>
+              <a:t>Holdinq</a:t>
+            </a:r>
+            <a:endParaRPr lang="en-US" sz="1150" dirty="0"/>
+          </a:p>
+        </p:txBody>
+      </p:sp>
+      <p:sp>
+        <p:nvSpPr>
+          <p:cNvPr id="58" name="chip-82"/>
+          <p:cNvSpPr/>
+          <p:nvPr/>
+        </p:nvSpPr>
+        <p:spPr>
+          <a:xfrm>
+            <a:off x="3246120" y="4338828"/>
+            <a:ext cx="1188720" cy="219456"/>
           </a:xfrm>
           <a:prstGeom prst="roundRect">
             <a:avLst>
@@ -7671,14 +8327,14 @@
       </p:sp>
       <p:sp>
         <p:nvSpPr>
-          <p:cNvPr id="39" name="chip-text-63"/>
-          <p:cNvSpPr txBox="1"/>
-          <p:nvPr/>
-        </p:nvSpPr>
-        <p:spPr>
-          <a:xfrm>
-            <a:off x="3794760" y="4114800"/>
-            <a:ext cx="1645920" cy="274320"/>
+          <p:cNvPr id="59" name="chip-text-83"/>
+          <p:cNvSpPr txBox="1"/>
+          <p:nvPr/>
+        </p:nvSpPr>
+        <p:spPr>
+          <a:xfrm>
+            <a:off x="3246120" y="4338828"/>
+            <a:ext cx="1188720" cy="219456"/>
           </a:xfrm>
           <a:prstGeom prst="rect">
             <a:avLst/>
@@ -7697,31 +8353,70 @@
               <a:buNone/>
             </a:pPr>
             <a:r>
-              <a:rPr lang="en-US" sz="1100" b="1" dirty="0">
+              <a:rPr lang="en-US" sz="1000" b="1" dirty="0">
                 <a:solidFill>
                   <a:schemeClr val="tx2"/>
                 </a:solidFill>
               </a:rPr>
               <a:t>ERP · qismən</a:t>
             </a:r>
-            <a:endParaRPr lang="en-US" sz="1100" dirty="0"/>
-          </a:p>
-        </p:txBody>
-      </p:sp>
-      <p:sp>
-        <p:nvSpPr>
-          <p:cNvPr id="40" name="stat-64"/>
+            <a:endParaRPr lang="en-US" sz="1000" dirty="0"/>
+          </a:p>
+        </p:txBody>
+      </p:sp>
+      <p:sp>
+        <p:nvSpPr>
+          <p:cNvPr id="60" name="text-84"/>
+          <p:cNvSpPr txBox="1"/>
+          <p:nvPr/>
+        </p:nvSpPr>
+        <p:spPr>
+          <a:xfrm>
+            <a:off x="4572000" y="4311396"/>
+            <a:ext cx="1261872" cy="274320"/>
+          </a:xfrm>
+          <a:prstGeom prst="rect">
+            <a:avLst/>
+          </a:prstGeom>
+          <a:noFill/>
+          <a:ln/>
+        </p:spPr>
+        <p:txBody>
+          <a:bodyPr wrap="square" lIns="0" tIns="0" rIns="0" bIns="0" rtlCol="0" anchor="ctr"/>
+          <a:lstStyle/>
+          <a:p>
+            <a:pPr algn="l" indent="0" marL="0">
+              <a:lnSpc>
+                <a:spcPct val="95000"/>
+              </a:lnSpc>
+              <a:buNone/>
+            </a:pPr>
+            <a:r>
+              <a:rPr lang="en-US" sz="900" i="1" dirty="0">
+                <a:solidFill>
+                  <a:schemeClr val="accent4"/>
+                </a:solidFill>
+              </a:rPr>
+              <a:t>büdcə prosesini tam əhatə etmir</a:t>
+            </a:r>
+            <a:endParaRPr lang="en-US" sz="900" dirty="0"/>
+          </a:p>
+        </p:txBody>
+      </p:sp>
+      <p:sp>
+        <p:nvSpPr>
+          <p:cNvPr id="61" name="stat-85"/>
           <p:cNvSpPr/>
           <p:nvPr/>
         </p:nvSpPr>
         <p:spPr>
           <a:xfrm>
-            <a:off x="5943600" y="1188720"/>
-            <a:ext cx="2743200" cy="1033272"/>
+            <a:off x="6080760" y="1188720"/>
+            <a:ext cx="2606040" cy="1078992"/>
           </a:xfrm>
           <a:prstGeom prst="roundRect">
             <a:avLst>
-              <a:gd name="adj" fmla="val 8850"/>
+              <a:gd name="adj" fmla="val 8475"/>
             </a:avLst>
           </a:prstGeom>
           <a:solidFill>
@@ -7739,14 +8434,14 @@
       </p:sp>
       <p:sp>
         <p:nvSpPr>
-          <p:cNvPr id="41" name="text-65"/>
-          <p:cNvSpPr txBox="1"/>
-          <p:nvPr/>
-        </p:nvSpPr>
-        <p:spPr>
-          <a:xfrm>
-            <a:off x="6172200" y="1280160"/>
-            <a:ext cx="2377440" cy="457200"/>
+          <p:cNvPr id="62" name="text-86"/>
+          <p:cNvSpPr txBox="1"/>
+          <p:nvPr/>
+        </p:nvSpPr>
+        <p:spPr>
+          <a:xfrm>
+            <a:off x="6300216" y="1261872"/>
+            <a:ext cx="2194560" cy="457200"/>
           </a:xfrm>
           <a:prstGeom prst="rect">
             <a:avLst/>
@@ -7773,7 +8468,7 @@
                 <a:ea typeface="Cambria" pitchFamily="34" charset="-122"/>
                 <a:cs typeface="Cambria" pitchFamily="34" charset="-120"/>
               </a:rPr>
-              <a:t>5 / 6</a:t>
+              <a:t>9 / 10</a:t>
             </a:r>
             <a:endParaRPr lang="en-US" sz="2800" dirty="0"/>
           </a:p>
@@ -7781,14 +8476,14 @@
       </p:sp>
       <p:sp>
         <p:nvSpPr>
-          <p:cNvPr id="42" name="text-66"/>
-          <p:cNvSpPr txBox="1"/>
-          <p:nvPr/>
-        </p:nvSpPr>
-        <p:spPr>
-          <a:xfrm>
-            <a:off x="6172200" y="1737360"/>
-            <a:ext cx="2377440" cy="411480"/>
+          <p:cNvPr id="63" name="text-87"/>
+          <p:cNvSpPr txBox="1"/>
+          <p:nvPr/>
+        </p:nvSpPr>
+        <p:spPr>
+          <a:xfrm>
+            <a:off x="6300216" y="1737360"/>
+            <a:ext cx="2194560" cy="219456"/>
           </a:xfrm>
           <a:prstGeom prst="rect">
             <a:avLst/>
@@ -7820,18 +8515,18 @@
       </p:sp>
       <p:sp>
         <p:nvSpPr>
-          <p:cNvPr id="43" name="stat-67"/>
+          <p:cNvPr id="64" name="stat-88"/>
           <p:cNvSpPr/>
           <p:nvPr/>
         </p:nvSpPr>
         <p:spPr>
           <a:xfrm>
-            <a:off x="5943600" y="2359152"/>
-            <a:ext cx="2743200" cy="1033272"/>
+            <a:off x="6080760" y="2377440"/>
+            <a:ext cx="2606040" cy="1078992"/>
           </a:xfrm>
           <a:prstGeom prst="roundRect">
             <a:avLst>
-              <a:gd name="adj" fmla="val 8850"/>
+              <a:gd name="adj" fmla="val 8475"/>
             </a:avLst>
           </a:prstGeom>
           <a:solidFill>
@@ -7849,14 +8544,14 @@
       </p:sp>
       <p:sp>
         <p:nvSpPr>
-          <p:cNvPr id="44" name="text-68"/>
-          <p:cNvSpPr txBox="1"/>
-          <p:nvPr/>
-        </p:nvSpPr>
-        <p:spPr>
-          <a:xfrm>
-            <a:off x="6172200" y="2450592"/>
-            <a:ext cx="2377440" cy="457200"/>
+          <p:cNvPr id="65" name="text-89"/>
+          <p:cNvSpPr txBox="1"/>
+          <p:nvPr/>
+        </p:nvSpPr>
+        <p:spPr>
+          <a:xfrm>
+            <a:off x="6300216" y="2450592"/>
+            <a:ext cx="2194560" cy="457200"/>
           </a:xfrm>
           <a:prstGeom prst="rect">
             <a:avLst/>
@@ -7883,7 +8578,7 @@
                 <a:ea typeface="Cambria" pitchFamily="34" charset="-122"/>
                 <a:cs typeface="Cambria" pitchFamily="34" charset="-120"/>
               </a:rPr>
-              <a:t>6 / 6</a:t>
+              <a:t>10 / 10</a:t>
             </a:r>
             <a:endParaRPr lang="en-US" sz="2800" dirty="0"/>
           </a:p>
@@ -7891,14 +8586,14 @@
       </p:sp>
       <p:sp>
         <p:nvSpPr>
-          <p:cNvPr id="45" name="text-69"/>
-          <p:cNvSpPr txBox="1"/>
-          <p:nvPr/>
-        </p:nvSpPr>
-        <p:spPr>
-          <a:xfrm>
-            <a:off x="6172200" y="2907792"/>
-            <a:ext cx="2377440" cy="411480"/>
+          <p:cNvPr id="66" name="text-90"/>
+          <p:cNvSpPr txBox="1"/>
+          <p:nvPr/>
+        </p:nvSpPr>
+        <p:spPr>
+          <a:xfrm>
+            <a:off x="6300216" y="2926080"/>
+            <a:ext cx="2194560" cy="411480"/>
           </a:xfrm>
           <a:prstGeom prst="rect">
             <a:avLst/>
@@ -7930,18 +8625,220 @@
       </p:sp>
       <p:sp>
         <p:nvSpPr>
-          <p:cNvPr id="46" name="scope-note-70"/>
+          <p:cNvPr id="67" name="company-dot-91"/>
           <p:cNvSpPr/>
           <p:nvPr/>
         </p:nvSpPr>
         <p:spPr>
           <a:xfrm>
-            <a:off x="5943600" y="3529584"/>
-            <a:ext cx="2743200" cy="1133856"/>
+            <a:off x="6300216" y="2029968"/>
+            <a:ext cx="128016" cy="128016"/>
+          </a:xfrm>
+          <a:prstGeom prst="ellipse">
+            <a:avLst/>
+          </a:prstGeom>
+          <a:solidFill>
+            <a:schemeClr val="accent3"/>
+          </a:solidFill>
+          <a:ln/>
+        </p:spPr>
+      </p:sp>
+      <p:sp>
+        <p:nvSpPr>
+          <p:cNvPr id="68" name="company-dot-92"/>
+          <p:cNvSpPr/>
+          <p:nvPr/>
+        </p:nvSpPr>
+        <p:spPr>
+          <a:xfrm>
+            <a:off x="6492240" y="2029968"/>
+            <a:ext cx="128016" cy="128016"/>
+          </a:xfrm>
+          <a:prstGeom prst="ellipse">
+            <a:avLst/>
+          </a:prstGeom>
+          <a:solidFill>
+            <a:schemeClr val="accent3"/>
+          </a:solidFill>
+          <a:ln/>
+        </p:spPr>
+      </p:sp>
+      <p:sp>
+        <p:nvSpPr>
+          <p:cNvPr id="69" name="company-dot-93"/>
+          <p:cNvSpPr/>
+          <p:nvPr/>
+        </p:nvSpPr>
+        <p:spPr>
+          <a:xfrm>
+            <a:off x="6684264" y="2029968"/>
+            <a:ext cx="128016" cy="128016"/>
+          </a:xfrm>
+          <a:prstGeom prst="ellipse">
+            <a:avLst/>
+          </a:prstGeom>
+          <a:solidFill>
+            <a:schemeClr val="accent3"/>
+          </a:solidFill>
+          <a:ln/>
+        </p:spPr>
+      </p:sp>
+      <p:sp>
+        <p:nvSpPr>
+          <p:cNvPr id="70" name="company-dot-94"/>
+          <p:cNvSpPr/>
+          <p:nvPr/>
+        </p:nvSpPr>
+        <p:spPr>
+          <a:xfrm>
+            <a:off x="6876288" y="2029968"/>
+            <a:ext cx="128016" cy="128016"/>
+          </a:xfrm>
+          <a:prstGeom prst="ellipse">
+            <a:avLst/>
+          </a:prstGeom>
+          <a:solidFill>
+            <a:schemeClr val="accent3"/>
+          </a:solidFill>
+          <a:ln/>
+        </p:spPr>
+      </p:sp>
+      <p:sp>
+        <p:nvSpPr>
+          <p:cNvPr id="71" name="company-dot-95"/>
+          <p:cNvSpPr/>
+          <p:nvPr/>
+        </p:nvSpPr>
+        <p:spPr>
+          <a:xfrm>
+            <a:off x="7068312" y="2029968"/>
+            <a:ext cx="128016" cy="128016"/>
+          </a:xfrm>
+          <a:prstGeom prst="ellipse">
+            <a:avLst/>
+          </a:prstGeom>
+          <a:solidFill>
+            <a:schemeClr val="accent3"/>
+          </a:solidFill>
+          <a:ln/>
+        </p:spPr>
+      </p:sp>
+      <p:sp>
+        <p:nvSpPr>
+          <p:cNvPr id="72" name="company-dot-96"/>
+          <p:cNvSpPr/>
+          <p:nvPr/>
+        </p:nvSpPr>
+        <p:spPr>
+          <a:xfrm>
+            <a:off x="7260336" y="2029968"/>
+            <a:ext cx="128016" cy="128016"/>
+          </a:xfrm>
+          <a:prstGeom prst="ellipse">
+            <a:avLst/>
+          </a:prstGeom>
+          <a:solidFill>
+            <a:schemeClr val="accent3"/>
+          </a:solidFill>
+          <a:ln/>
+        </p:spPr>
+      </p:sp>
+      <p:sp>
+        <p:nvSpPr>
+          <p:cNvPr id="73" name="company-dot-97"/>
+          <p:cNvSpPr/>
+          <p:nvPr/>
+        </p:nvSpPr>
+        <p:spPr>
+          <a:xfrm>
+            <a:off x="7452360" y="2029968"/>
+            <a:ext cx="128016" cy="128016"/>
+          </a:xfrm>
+          <a:prstGeom prst="ellipse">
+            <a:avLst/>
+          </a:prstGeom>
+          <a:solidFill>
+            <a:schemeClr val="accent3"/>
+          </a:solidFill>
+          <a:ln/>
+        </p:spPr>
+      </p:sp>
+      <p:sp>
+        <p:nvSpPr>
+          <p:cNvPr id="74" name="company-dot-98"/>
+          <p:cNvSpPr/>
+          <p:nvPr/>
+        </p:nvSpPr>
+        <p:spPr>
+          <a:xfrm>
+            <a:off x="7644384" y="2029968"/>
+            <a:ext cx="128016" cy="128016"/>
+          </a:xfrm>
+          <a:prstGeom prst="ellipse">
+            <a:avLst/>
+          </a:prstGeom>
+          <a:solidFill>
+            <a:schemeClr val="accent3"/>
+          </a:solidFill>
+          <a:ln/>
+        </p:spPr>
+      </p:sp>
+      <p:sp>
+        <p:nvSpPr>
+          <p:cNvPr id="75" name="company-dot-99"/>
+          <p:cNvSpPr/>
+          <p:nvPr/>
+        </p:nvSpPr>
+        <p:spPr>
+          <a:xfrm>
+            <a:off x="7836408" y="2029968"/>
+            <a:ext cx="128016" cy="128016"/>
+          </a:xfrm>
+          <a:prstGeom prst="ellipse">
+            <a:avLst/>
+          </a:prstGeom>
+          <a:solidFill>
+            <a:schemeClr val="accent3"/>
+          </a:solidFill>
+          <a:ln/>
+        </p:spPr>
+      </p:sp>
+      <p:sp>
+        <p:nvSpPr>
+          <p:cNvPr id="76" name="company-dot-100"/>
+          <p:cNvSpPr/>
+          <p:nvPr/>
+        </p:nvSpPr>
+        <p:spPr>
+          <a:xfrm>
+            <a:off x="8028432" y="2029968"/>
+            <a:ext cx="128016" cy="128016"/>
+          </a:xfrm>
+          <a:prstGeom prst="ellipse">
+            <a:avLst/>
+          </a:prstGeom>
+          <a:solidFill>
+            <a:schemeClr val="accent4">
+              <a:alpha val="45000"/>
+            </a:schemeClr>
+          </a:solidFill>
+          <a:ln/>
+        </p:spPr>
+      </p:sp>
+      <p:sp>
+        <p:nvSpPr>
+          <p:cNvPr id="77" name="scope-note-101"/>
+          <p:cNvSpPr/>
+          <p:nvPr/>
+        </p:nvSpPr>
+        <p:spPr>
+          <a:xfrm>
+            <a:off x="6080760" y="3566160"/>
+            <a:ext cx="2606040" cy="1115568"/>
           </a:xfrm>
           <a:prstGeom prst="roundRect">
             <a:avLst>
-              <a:gd name="adj" fmla="val 8065"/>
+              <a:gd name="adj" fmla="val 8197"/>
             </a:avLst>
           </a:prstGeom>
           <a:solidFill>
@@ -7952,7 +8849,7 @@
       </p:sp>
       <p:pic>
         <p:nvPicPr>
-          <p:cNvPr id="47" name="icon-LuInfo-71" descr="Qeyd">    </p:cNvPr>
+          <p:cNvPr id="78" name="icon-LuInfo-102" descr="Qeyd">    </p:cNvPr>
           <p:cNvPicPr>
             <a:picLocks noChangeAspect="1"/>
           </p:cNvPicPr>
@@ -7966,7 +8863,7 @@
         </p:blipFill>
         <p:spPr>
           <a:xfrm>
-            <a:off x="6144768" y="3675888"/>
+            <a:off x="6281928" y="3703320"/>
             <a:ext cx="219456" cy="219456"/>
           </a:xfrm>
           <a:prstGeom prst="rect">
@@ -7976,14 +8873,14 @@
       </p:pic>
       <p:sp>
         <p:nvSpPr>
-          <p:cNvPr id="48" name="text-72"/>
-          <p:cNvSpPr txBox="1"/>
-          <p:nvPr/>
-        </p:nvSpPr>
-        <p:spPr>
-          <a:xfrm>
-            <a:off x="6446520" y="3657600"/>
-            <a:ext cx="2103120" cy="256032"/>
+          <p:cNvPr id="79" name="text-103"/>
+          <p:cNvSpPr txBox="1"/>
+          <p:nvPr/>
+        </p:nvSpPr>
+        <p:spPr>
+          <a:xfrm>
+            <a:off x="6583680" y="3685032"/>
+            <a:ext cx="1965960" cy="256032"/>
           </a:xfrm>
           <a:prstGeom prst="rect">
             <a:avLst/>
@@ -8015,14 +8912,14 @@
       </p:sp>
       <p:sp>
         <p:nvSpPr>
-          <p:cNvPr id="49" name="text-73"/>
-          <p:cNvSpPr txBox="1"/>
-          <p:nvPr/>
-        </p:nvSpPr>
-        <p:spPr>
-          <a:xfrm>
-            <a:off x="6144768" y="3959352"/>
-            <a:ext cx="2423160" cy="640080"/>
+          <p:cNvPr id="80" name="text-104"/>
+          <p:cNvSpPr txBox="1"/>
+          <p:nvPr/>
+        </p:nvSpPr>
+        <p:spPr>
+          <a:xfrm>
+            <a:off x="6281928" y="3986784"/>
+            <a:ext cx="2240280" cy="640080"/>
           </a:xfrm>
           <a:prstGeom prst="rect">
             <a:avLst/>
@@ -8046,7 +8943,7 @@
                   <a:schemeClr val="tx2"/>
                 </a:solidFill>
               </a:rPr>
-              <a:t>Nəticələr yalnız bu 6 müsahibəyə aiddir. Ödəməyə hazırlıq və pilot razılığı ayrıca yoxlanılacaq.</a:t>
+              <a:t>Nəticələr yalnız bu 10 müsahibəyə aiddir. Ödəməyə hazırlıq və pilot razılığı ayrıca yoxlanılacaq.</a:t>
             </a:r>
             <a:endParaRPr lang="en-US" sz="1050" dirty="0"/>
           </a:p>
@@ -8127,7 +9024,7 @@
       </p:grpSpPr>
       <p:sp>
         <p:nvSpPr>
-          <p:cNvPr id="2" name="kicker-74"/>
+          <p:cNvPr id="2" name="kicker-105"/>
           <p:cNvSpPr txBox="1"/>
           <p:nvPr/>
         </p:nvSpPr>
@@ -8207,7 +9104,7 @@
       </p:sp>
       <p:sp>
         <p:nvSpPr>
-          <p:cNvPr id="4" name="criteria-75"/>
+          <p:cNvPr id="4" name="criteria-106"/>
           <p:cNvSpPr/>
           <p:nvPr/>
         </p:nvSpPr>
@@ -8236,7 +9133,7 @@
       </p:sp>
       <p:sp>
         <p:nvSpPr>
-          <p:cNvPr id="5" name="text-76"/>
+          <p:cNvPr id="5" name="text-107"/>
           <p:cNvSpPr txBox="1"/>
           <p:nvPr/>
         </p:nvSpPr>
@@ -8275,7 +9172,7 @@
       </p:sp>
       <p:sp>
         <p:nvSpPr>
-          <p:cNvPr id="6" name="icon-bg-77"/>
+          <p:cNvPr id="6" name="icon-bg-108"/>
           <p:cNvSpPr/>
           <p:nvPr/>
         </p:nvSpPr>
@@ -8297,7 +9194,7 @@
       </p:sp>
       <p:pic>
         <p:nvPicPr>
-          <p:cNvPr id="7" name="icon-LuNetwork-78" descr="Network">    </p:cNvPr>
+          <p:cNvPr id="7" name="icon-LuNetwork-109" descr="Network">    </p:cNvPr>
           <p:cNvPicPr>
             <a:picLocks noChangeAspect="1"/>
           </p:cNvPicPr>
@@ -8321,7 +9218,7 @@
       </p:pic>
       <p:sp>
         <p:nvSpPr>
-          <p:cNvPr id="8" name="text-79"/>
+          <p:cNvPr id="8" name="text-110"/>
           <p:cNvSpPr txBox="1"/>
           <p:nvPr/>
         </p:nvSpPr>
@@ -8360,7 +9257,7 @@
       </p:sp>
       <p:sp>
         <p:nvSpPr>
-          <p:cNvPr id="9" name="text-80"/>
+          <p:cNvPr id="9" name="text-111"/>
           <p:cNvSpPr txBox="1"/>
           <p:nvPr/>
         </p:nvSpPr>
@@ -8391,7 +9288,7 @@
                   <a:schemeClr val="tx2"/>
                 </a:solidFill>
               </a:rPr>
-              <a:t>Çoxlu departament, xərc mərkəzi və təsdiq səviyyəsi</a:t>
+              <a:t>Departament sayının çoxluğu, xərc mərkəzi və təsdiq səviyyəsi</a:t>
             </a:r>
             <a:endParaRPr lang="en-US" sz="1150" dirty="0"/>
           </a:p>
@@ -8399,7 +9296,7 @@
       </p:sp>
       <p:sp>
         <p:nvSpPr>
-          <p:cNvPr id="10" name="icon-bg-81"/>
+          <p:cNvPr id="10" name="icon-bg-112"/>
           <p:cNvSpPr/>
           <p:nvPr/>
         </p:nvSpPr>
@@ -8421,7 +9318,7 @@
       </p:sp>
       <p:pic>
         <p:nvPicPr>
-          <p:cNvPr id="11" name="icon-LuFileSpreadsheet-82" descr="FileSpreadsheet">    </p:cNvPr>
+          <p:cNvPr id="11" name="icon-LuFileSpreadsheet-113" descr="FileSpreadsheet">    </p:cNvPr>
           <p:cNvPicPr>
             <a:picLocks noChangeAspect="1"/>
           </p:cNvPicPr>
@@ -8445,7 +9342,7 @@
       </p:pic>
       <p:sp>
         <p:nvSpPr>
-          <p:cNvPr id="12" name="text-83"/>
+          <p:cNvPr id="12" name="text-114"/>
           <p:cNvSpPr txBox="1"/>
           <p:nvPr/>
         </p:nvSpPr>
@@ -8484,7 +9381,7 @@
       </p:sp>
       <p:sp>
         <p:nvSpPr>
-          <p:cNvPr id="13" name="text-84"/>
+          <p:cNvPr id="13" name="text-115"/>
           <p:cNvSpPr txBox="1"/>
           <p:nvPr/>
         </p:nvSpPr>
@@ -8523,7 +9420,7 @@
       </p:sp>
       <p:sp>
         <p:nvSpPr>
-          <p:cNvPr id="14" name="icon-bg-85"/>
+          <p:cNvPr id="14" name="icon-bg-116"/>
           <p:cNvSpPr/>
           <p:nvPr/>
         </p:nvSpPr>
@@ -8545,7 +9442,7 @@
       </p:sp>
       <p:pic>
         <p:nvPicPr>
-          <p:cNvPr id="15" name="icon-LuWallet-86" descr="Wallet">    </p:cNvPr>
+          <p:cNvPr id="15" name="icon-LuWallet-117" descr="Wallet">    </p:cNvPr>
           <p:cNvPicPr>
             <a:picLocks noChangeAspect="1"/>
           </p:cNvPicPr>
@@ -8569,7 +9466,7 @@
       </p:pic>
       <p:sp>
         <p:nvSpPr>
-          <p:cNvPr id="16" name="text-87"/>
+          <p:cNvPr id="16" name="text-118"/>
           <p:cNvSpPr txBox="1"/>
           <p:nvPr/>
         </p:nvSpPr>
@@ -8608,7 +9505,7 @@
       </p:sp>
       <p:sp>
         <p:nvSpPr>
-          <p:cNvPr id="17" name="text-88"/>
+          <p:cNvPr id="17" name="text-119"/>
           <p:cNvSpPr txBox="1"/>
           <p:nvPr/>
         </p:nvSpPr>
@@ -8647,7 +9544,7 @@
       </p:sp>
       <p:sp>
         <p:nvSpPr>
-          <p:cNvPr id="18" name="chip-89"/>
+          <p:cNvPr id="18" name="chip-120"/>
           <p:cNvSpPr/>
           <p:nvPr/>
         </p:nvSpPr>
@@ -8671,7 +9568,7 @@
       </p:sp>
       <p:sp>
         <p:nvSpPr>
-          <p:cNvPr id="19" name="chip-text-90"/>
+          <p:cNvPr id="19" name="chip-text-121"/>
           <p:cNvSpPr txBox="1"/>
           <p:nvPr/>
         </p:nvSpPr>
@@ -8710,7 +9607,7 @@
       </p:sp>
       <p:sp>
         <p:nvSpPr>
-          <p:cNvPr id="20" name="text-91"/>
+          <p:cNvPr id="20" name="text-122"/>
           <p:cNvSpPr txBox="1"/>
           <p:nvPr/>
         </p:nvSpPr>
@@ -8749,7 +9646,7 @@
       </p:sp>
       <p:sp>
         <p:nvSpPr>
-          <p:cNvPr id="21" name="alternatives-92"/>
+          <p:cNvPr id="21" name="alternatives-123"/>
           <p:cNvSpPr/>
           <p:nvPr/>
         </p:nvSpPr>
@@ -8778,7 +9675,7 @@
       </p:sp>
       <p:sp>
         <p:nvSpPr>
-          <p:cNvPr id="22" name="text-93"/>
+          <p:cNvPr id="22" name="text-124"/>
           <p:cNvSpPr txBox="1"/>
           <p:nvPr/>
         </p:nvSpPr>
@@ -8817,7 +9714,7 @@
       </p:sp>
       <p:sp>
         <p:nvSpPr>
-          <p:cNvPr id="23" name="text-94"/>
+          <p:cNvPr id="23" name="text-125"/>
           <p:cNvSpPr txBox="1"/>
           <p:nvPr/>
         </p:nvSpPr>
@@ -8856,7 +9753,7 @@
       </p:sp>
       <p:sp>
         <p:nvSpPr>
-          <p:cNvPr id="24" name="text-95"/>
+          <p:cNvPr id="24" name="text-126"/>
           <p:cNvSpPr txBox="1"/>
           <p:nvPr/>
         </p:nvSpPr>
@@ -8895,7 +9792,7 @@
       </p:sp>
       <p:sp>
         <p:nvSpPr>
-          <p:cNvPr id="25" name="alt-line-96"/>
+          <p:cNvPr id="25" name="alt-line-127"/>
           <p:cNvSpPr/>
           <p:nvPr/>
         </p:nvSpPr>
@@ -8918,7 +9815,7 @@
       </p:sp>
       <p:sp>
         <p:nvSpPr>
-          <p:cNvPr id="26" name="text-97"/>
+          <p:cNvPr id="26" name="text-128"/>
           <p:cNvSpPr txBox="1"/>
           <p:nvPr/>
         </p:nvSpPr>
@@ -8957,7 +9854,7 @@
       </p:sp>
       <p:sp>
         <p:nvSpPr>
-          <p:cNvPr id="27" name="text-98"/>
+          <p:cNvPr id="27" name="text-129"/>
           <p:cNvSpPr txBox="1"/>
           <p:nvPr/>
         </p:nvSpPr>
@@ -8996,7 +9893,7 @@
       </p:sp>
       <p:sp>
         <p:nvSpPr>
-          <p:cNvPr id="28" name="alt-line-99"/>
+          <p:cNvPr id="28" name="alt-line-130"/>
           <p:cNvSpPr/>
           <p:nvPr/>
         </p:nvSpPr>
@@ -9019,7 +9916,7 @@
       </p:sp>
       <p:sp>
         <p:nvSpPr>
-          <p:cNvPr id="29" name="text-100"/>
+          <p:cNvPr id="29" name="text-131"/>
           <p:cNvSpPr txBox="1"/>
           <p:nvPr/>
         </p:nvSpPr>
@@ -9058,7 +9955,7 @@
       </p:sp>
       <p:sp>
         <p:nvSpPr>
-          <p:cNvPr id="30" name="text-101"/>
+          <p:cNvPr id="30" name="text-132"/>
           <p:cNvSpPr txBox="1"/>
           <p:nvPr/>
         </p:nvSpPr>
@@ -9097,7 +9994,7 @@
       </p:sp>
       <p:sp>
         <p:nvSpPr>
-          <p:cNvPr id="31" name="text-102"/>
+          <p:cNvPr id="31" name="text-133"/>
           <p:cNvSpPr txBox="1"/>
           <p:nvPr/>
         </p:nvSpPr>
@@ -9209,7 +10106,7 @@
       </p:grpSpPr>
       <p:sp>
         <p:nvSpPr>
-          <p:cNvPr id="2" name="kicker-103"/>
+          <p:cNvPr id="2" name="kicker-134"/>
           <p:cNvSpPr txBox="1"/>
           <p:nvPr/>
         </p:nvSpPr>
@@ -9289,7 +10186,7 @@
       </p:sp>
       <p:sp>
         <p:nvSpPr>
-          <p:cNvPr id="4" name="process-104"/>
+          <p:cNvPr id="4" name="process-135"/>
           <p:cNvSpPr/>
           <p:nvPr/>
         </p:nvSpPr>
@@ -9341,7 +10238,7 @@
       </p:sp>
       <p:sp>
         <p:nvSpPr>
-          <p:cNvPr id="6" name="num-105"/>
+          <p:cNvPr id="6" name="num-136"/>
           <p:cNvSpPr/>
           <p:nvPr/>
         </p:nvSpPr>
@@ -9361,7 +10258,7 @@
       </p:sp>
       <p:sp>
         <p:nvSpPr>
-          <p:cNvPr id="7" name="num-text-106"/>
+          <p:cNvPr id="7" name="num-text-137"/>
           <p:cNvSpPr txBox="1"/>
           <p:nvPr/>
         </p:nvSpPr>
@@ -9400,7 +10297,7 @@
       </p:sp>
       <p:sp>
         <p:nvSpPr>
-          <p:cNvPr id="8" name="text-107"/>
+          <p:cNvPr id="8" name="text-138"/>
           <p:cNvSpPr txBox="1"/>
           <p:nvPr/>
         </p:nvSpPr>
@@ -9442,7 +10339,7 @@
       </p:sp>
       <p:sp>
         <p:nvSpPr>
-          <p:cNvPr id="9" name="text-108"/>
+          <p:cNvPr id="9" name="text-139"/>
           <p:cNvSpPr txBox="1"/>
           <p:nvPr/>
         </p:nvSpPr>
@@ -9481,7 +10378,7 @@
       </p:sp>
       <p:sp>
         <p:nvSpPr>
-          <p:cNvPr id="10" name="num-109"/>
+          <p:cNvPr id="10" name="num-140"/>
           <p:cNvSpPr/>
           <p:nvPr/>
         </p:nvSpPr>
@@ -9501,7 +10398,7 @@
       </p:sp>
       <p:sp>
         <p:nvSpPr>
-          <p:cNvPr id="11" name="num-text-110"/>
+          <p:cNvPr id="11" name="num-text-141"/>
           <p:cNvSpPr txBox="1"/>
           <p:nvPr/>
         </p:nvSpPr>
@@ -9540,7 +10437,7 @@
       </p:sp>
       <p:sp>
         <p:nvSpPr>
-          <p:cNvPr id="12" name="text-111"/>
+          <p:cNvPr id="12" name="text-142"/>
           <p:cNvSpPr txBox="1"/>
           <p:nvPr/>
         </p:nvSpPr>
@@ -9582,7 +10479,7 @@
       </p:sp>
       <p:sp>
         <p:nvSpPr>
-          <p:cNvPr id="13" name="text-112"/>
+          <p:cNvPr id="13" name="text-143"/>
           <p:cNvSpPr txBox="1"/>
           <p:nvPr/>
         </p:nvSpPr>
@@ -9621,7 +10518,7 @@
       </p:sp>
       <p:sp>
         <p:nvSpPr>
-          <p:cNvPr id="14" name="num-113"/>
+          <p:cNvPr id="14" name="num-144"/>
           <p:cNvSpPr/>
           <p:nvPr/>
         </p:nvSpPr>
@@ -9641,7 +10538,7 @@
       </p:sp>
       <p:sp>
         <p:nvSpPr>
-          <p:cNvPr id="15" name="num-text-114"/>
+          <p:cNvPr id="15" name="num-text-145"/>
           <p:cNvSpPr txBox="1"/>
           <p:nvPr/>
         </p:nvSpPr>
@@ -9680,7 +10577,7 @@
       </p:sp>
       <p:sp>
         <p:nvSpPr>
-          <p:cNvPr id="16" name="text-115"/>
+          <p:cNvPr id="16" name="text-146"/>
           <p:cNvSpPr txBox="1"/>
           <p:nvPr/>
         </p:nvSpPr>
@@ -9722,7 +10619,7 @@
       </p:sp>
       <p:sp>
         <p:nvSpPr>
-          <p:cNvPr id="17" name="text-116"/>
+          <p:cNvPr id="17" name="text-147"/>
           <p:cNvSpPr txBox="1"/>
           <p:nvPr/>
         </p:nvSpPr>
@@ -9761,7 +10658,7 @@
       </p:sp>
       <p:sp>
         <p:nvSpPr>
-          <p:cNvPr id="18" name="num-117"/>
+          <p:cNvPr id="18" name="num-148"/>
           <p:cNvSpPr/>
           <p:nvPr/>
         </p:nvSpPr>
@@ -9781,7 +10678,7 @@
       </p:sp>
       <p:sp>
         <p:nvSpPr>
-          <p:cNvPr id="19" name="num-text-118"/>
+          <p:cNvPr id="19" name="num-text-149"/>
           <p:cNvSpPr txBox="1"/>
           <p:nvPr/>
         </p:nvSpPr>
@@ -9820,7 +10717,7 @@
       </p:sp>
       <p:sp>
         <p:nvSpPr>
-          <p:cNvPr id="20" name="text-119"/>
+          <p:cNvPr id="20" name="text-150"/>
           <p:cNvSpPr txBox="1"/>
           <p:nvPr/>
         </p:nvSpPr>
@@ -9862,7 +10759,7 @@
       </p:sp>
       <p:sp>
         <p:nvSpPr>
-          <p:cNvPr id="21" name="text-120"/>
+          <p:cNvPr id="21" name="text-151"/>
           <p:cNvSpPr txBox="1"/>
           <p:nvPr/>
         </p:nvSpPr>
@@ -9901,7 +10798,7 @@
       </p:sp>
       <p:sp>
         <p:nvSpPr>
-          <p:cNvPr id="22" name="text-121"/>
+          <p:cNvPr id="22" name="text-152"/>
           <p:cNvSpPr txBox="1"/>
           <p:nvPr/>
         </p:nvSpPr>
@@ -9940,7 +10837,7 @@
       </p:sp>
       <p:sp>
         <p:nvSpPr>
-          <p:cNvPr id="23" name="diff-card-122"/>
+          <p:cNvPr id="23" name="diff-card-153"/>
           <p:cNvSpPr/>
           <p:nvPr/>
         </p:nvSpPr>
@@ -9969,7 +10866,7 @@
       </p:sp>
       <p:sp>
         <p:nvSpPr>
-          <p:cNvPr id="24" name="chip-123"/>
+          <p:cNvPr id="24" name="chip-154"/>
           <p:cNvSpPr/>
           <p:nvPr/>
         </p:nvSpPr>
@@ -9993,7 +10890,7 @@
       </p:sp>
       <p:sp>
         <p:nvSpPr>
-          <p:cNvPr id="25" name="chip-text-124"/>
+          <p:cNvPr id="25" name="chip-text-155"/>
           <p:cNvSpPr txBox="1"/>
           <p:nvPr/>
         </p:nvSpPr>
@@ -10032,7 +10929,7 @@
       </p:sp>
       <p:pic>
         <p:nvPicPr>
-          <p:cNvPr id="26" name="icon-LuCircleCheck-125" descr="CircleCheck">    </p:cNvPr>
+          <p:cNvPr id="26" name="icon-LuCircleCheck-156" descr="CircleCheck">    </p:cNvPr>
           <p:cNvPicPr>
             <a:picLocks noChangeAspect="1"/>
           </p:cNvPicPr>
@@ -10056,7 +10953,7 @@
       </p:pic>
       <p:sp>
         <p:nvSpPr>
-          <p:cNvPr id="27" name="text-126"/>
+          <p:cNvPr id="27" name="text-157"/>
           <p:cNvSpPr txBox="1"/>
           <p:nvPr/>
         </p:nvSpPr>
@@ -10095,7 +10992,7 @@
       </p:sp>
       <p:pic>
         <p:nvPicPr>
-          <p:cNvPr id="28" name="icon-LuCircleCheck-127" descr="CircleCheck">    </p:cNvPr>
+          <p:cNvPr id="28" name="icon-LuCircleCheck-158" descr="CircleCheck">    </p:cNvPr>
           <p:cNvPicPr>
             <a:picLocks noChangeAspect="1"/>
           </p:cNvPicPr>
@@ -10119,7 +11016,7 @@
       </p:pic>
       <p:sp>
         <p:nvSpPr>
-          <p:cNvPr id="29" name="text-128"/>
+          <p:cNvPr id="29" name="text-159"/>
           <p:cNvSpPr txBox="1"/>
           <p:nvPr/>
         </p:nvSpPr>
@@ -10158,7 +11055,7 @@
       </p:sp>
       <p:pic>
         <p:nvPicPr>
-          <p:cNvPr id="30" name="icon-LuCircleCheck-129" descr="CircleCheck">    </p:cNvPr>
+          <p:cNvPr id="30" name="icon-LuCircleCheck-160" descr="CircleCheck">    </p:cNvPr>
           <p:cNvPicPr>
             <a:picLocks noChangeAspect="1"/>
           </p:cNvPicPr>
@@ -10182,7 +11079,7 @@
       </p:pic>
       <p:sp>
         <p:nvSpPr>
-          <p:cNvPr id="31" name="text-130"/>
+          <p:cNvPr id="31" name="text-161"/>
           <p:cNvSpPr txBox="1"/>
           <p:nvPr/>
         </p:nvSpPr>
@@ -10221,7 +11118,7 @@
       </p:sp>
       <p:sp>
         <p:nvSpPr>
-          <p:cNvPr id="32" name="diff-card-131"/>
+          <p:cNvPr id="32" name="diff-card-162"/>
           <p:cNvSpPr/>
           <p:nvPr/>
         </p:nvSpPr>
@@ -10250,7 +11147,7 @@
       </p:sp>
       <p:sp>
         <p:nvSpPr>
-          <p:cNvPr id="33" name="chip-132"/>
+          <p:cNvPr id="33" name="chip-163"/>
           <p:cNvSpPr/>
           <p:nvPr/>
         </p:nvSpPr>
@@ -10274,7 +11171,7 @@
       </p:sp>
       <p:sp>
         <p:nvSpPr>
-          <p:cNvPr id="34" name="chip-text-133"/>
+          <p:cNvPr id="34" name="chip-text-164"/>
           <p:cNvSpPr txBox="1"/>
           <p:nvPr/>
         </p:nvSpPr>
@@ -10313,7 +11210,7 @@
       </p:sp>
       <p:pic>
         <p:nvPicPr>
-          <p:cNvPr id="35" name="icon-LuTarget-134" descr="Target">    </p:cNvPr>
+          <p:cNvPr id="35" name="icon-LuTarget-165" descr="Target">    </p:cNvPr>
           <p:cNvPicPr>
             <a:picLocks noChangeAspect="1"/>
           </p:cNvPicPr>
@@ -10337,7 +11234,7 @@
       </p:pic>
       <p:sp>
         <p:nvSpPr>
-          <p:cNvPr id="36" name="text-135"/>
+          <p:cNvPr id="36" name="text-166"/>
           <p:cNvSpPr txBox="1"/>
           <p:nvPr/>
         </p:nvSpPr>
@@ -10376,7 +11273,7 @@
       </p:sp>
       <p:pic>
         <p:nvPicPr>
-          <p:cNvPr id="37" name="icon-LuTarget-136" descr="Target">    </p:cNvPr>
+          <p:cNvPr id="37" name="icon-LuTarget-167" descr="Target">    </p:cNvPr>
           <p:cNvPicPr>
             <a:picLocks noChangeAspect="1"/>
           </p:cNvPicPr>
@@ -10400,7 +11297,7 @@
       </p:pic>
       <p:sp>
         <p:nvSpPr>
-          <p:cNvPr id="38" name="text-137"/>
+          <p:cNvPr id="38" name="text-168"/>
           <p:cNvSpPr txBox="1"/>
           <p:nvPr/>
         </p:nvSpPr>
@@ -10512,7 +11409,7 @@
       </p:grpSpPr>
       <p:sp>
         <p:nvSpPr>
-          <p:cNvPr id="2" name="kicker-138"/>
+          <p:cNvPr id="2" name="kicker-169"/>
           <p:cNvSpPr txBox="1"/>
           <p:nvPr/>
         </p:nvSpPr>
@@ -10592,7 +11489,7 @@
       </p:sp>
       <p:sp>
         <p:nvSpPr>
-          <p:cNvPr id="4" name="shot-frame-139"/>
+          <p:cNvPr id="4" name="shot-frame-170"/>
           <p:cNvSpPr/>
           <p:nvPr/>
         </p:nvSpPr>
@@ -10621,7 +11518,7 @@
       </p:sp>
       <p:pic>
         <p:nvPicPr>
-          <p:cNvPr id="5" name="screenshot-140" descr="Planlama ekranı: Plan 2027, Proqnoz 2026, fərq və departamentlər üzrə 2025 fakt, 2026 büdcə və proqnoz, 2027 plan qrafiki">    </p:cNvPr>
+          <p:cNvPr id="5" name="screenshot-171" descr="Planlama ekranı: Plan 2027, Proqnoz 2026, fərq və departamentlər üzrə 2025 fakt, 2026 büdcə və proqnoz, 2027 plan qrafiki">    </p:cNvPr>
           <p:cNvPicPr>
             <a:picLocks noChangeAspect="1"/>
           </p:cNvPicPr>
@@ -10645,7 +11542,7 @@
       </p:pic>
       <p:sp>
         <p:nvSpPr>
-          <p:cNvPr id="6" name="chip-141"/>
+          <p:cNvPr id="6" name="chip-172"/>
           <p:cNvSpPr/>
           <p:nvPr/>
         </p:nvSpPr>
@@ -10669,7 +11566,7 @@
       </p:sp>
       <p:sp>
         <p:nvSpPr>
-          <p:cNvPr id="7" name="chip-text-142"/>
+          <p:cNvPr id="7" name="chip-text-173"/>
           <p:cNvSpPr txBox="1"/>
           <p:nvPr/>
         </p:nvSpPr>
@@ -10708,7 +11605,7 @@
       </p:sp>
       <p:sp>
         <p:nvSpPr>
-          <p:cNvPr id="8" name="num-143"/>
+          <p:cNvPr id="8" name="num-174"/>
           <p:cNvSpPr/>
           <p:nvPr/>
         </p:nvSpPr>
@@ -10728,7 +11625,7 @@
       </p:sp>
       <p:sp>
         <p:nvSpPr>
-          <p:cNvPr id="9" name="num-text-144"/>
+          <p:cNvPr id="9" name="num-text-175"/>
           <p:cNvSpPr txBox="1"/>
           <p:nvPr/>
         </p:nvSpPr>
@@ -10767,7 +11664,7 @@
       </p:sp>
       <p:sp>
         <p:nvSpPr>
-          <p:cNvPr id="10" name="text-145"/>
+          <p:cNvPr id="10" name="text-176"/>
           <p:cNvSpPr txBox="1"/>
           <p:nvPr/>
         </p:nvSpPr>
@@ -10809,7 +11706,7 @@
       </p:sp>
       <p:sp>
         <p:nvSpPr>
-          <p:cNvPr id="11" name="text-146"/>
+          <p:cNvPr id="11" name="text-177"/>
           <p:cNvSpPr txBox="1"/>
           <p:nvPr/>
         </p:nvSpPr>
@@ -10848,7 +11745,7 @@
       </p:sp>
       <p:sp>
         <p:nvSpPr>
-          <p:cNvPr id="12" name="text-147"/>
+          <p:cNvPr id="12" name="text-178"/>
           <p:cNvSpPr txBox="1"/>
           <p:nvPr/>
         </p:nvSpPr>
@@ -10887,7 +11784,7 @@
       </p:sp>
       <p:sp>
         <p:nvSpPr>
-          <p:cNvPr id="13" name="text-148"/>
+          <p:cNvPr id="13" name="text-179"/>
           <p:cNvSpPr txBox="1"/>
           <p:nvPr/>
         </p:nvSpPr>
@@ -10926,7 +11823,7 @@
       </p:sp>
       <p:sp>
         <p:nvSpPr>
-          <p:cNvPr id="14" name="text-149"/>
+          <p:cNvPr id="14" name="text-180"/>
           <p:cNvSpPr txBox="1"/>
           <p:nvPr/>
         </p:nvSpPr>
@@ -10965,7 +11862,7 @@
       </p:sp>
       <p:sp>
         <p:nvSpPr>
-          <p:cNvPr id="15" name="text-150"/>
+          <p:cNvPr id="15" name="text-181"/>
           <p:cNvSpPr txBox="1"/>
           <p:nvPr/>
         </p:nvSpPr>
@@ -11077,7 +11974,7 @@
       </p:grpSpPr>
       <p:sp>
         <p:nvSpPr>
-          <p:cNvPr id="2" name="kicker-151"/>
+          <p:cNvPr id="2" name="kicker-182"/>
           <p:cNvSpPr txBox="1"/>
           <p:nvPr/>
         </p:nvSpPr>
@@ -11157,7 +12054,7 @@
       </p:sp>
       <p:sp>
         <p:nvSpPr>
-          <p:cNvPr id="4" name="num-152"/>
+          <p:cNvPr id="4" name="num-183"/>
           <p:cNvSpPr/>
           <p:nvPr/>
         </p:nvSpPr>
@@ -11177,7 +12074,7 @@
       </p:sp>
       <p:sp>
         <p:nvSpPr>
-          <p:cNvPr id="5" name="num-text-153"/>
+          <p:cNvPr id="5" name="num-text-184"/>
           <p:cNvSpPr txBox="1"/>
           <p:nvPr/>
         </p:nvSpPr>
@@ -11216,7 +12113,7 @@
       </p:sp>
       <p:sp>
         <p:nvSpPr>
-          <p:cNvPr id="6" name="text-154"/>
+          <p:cNvPr id="6" name="text-185"/>
           <p:cNvSpPr txBox="1"/>
           <p:nvPr/>
         </p:nvSpPr>
@@ -11255,7 +12152,7 @@
       </p:sp>
       <p:sp>
         <p:nvSpPr>
-          <p:cNvPr id="7" name="text-155"/>
+          <p:cNvPr id="7" name="text-186"/>
           <p:cNvSpPr txBox="1"/>
           <p:nvPr/>
         </p:nvSpPr>
@@ -11294,7 +12191,7 @@
       </p:sp>
       <p:sp>
         <p:nvSpPr>
-          <p:cNvPr id="8" name="shot-frame-156"/>
+          <p:cNvPr id="8" name="shot-frame-187"/>
           <p:cNvSpPr/>
           <p:nvPr/>
         </p:nvSpPr>
@@ -11323,7 +12220,7 @@
       </p:sp>
       <p:pic>
         <p:nvPicPr>
-          <p:cNvPr id="9" name="screenshot-157" descr="Satınalma sorğusunda büdcə yoxlaması: büdcəni aşır, sorğudan sonra qalıq mənfi">    </p:cNvPr>
+          <p:cNvPr id="9" name="screenshot-188" descr="Satınalma sorğusunda büdcə yoxlaması: büdcəni aşır, sorğudan sonra qalıq mənfi">    </p:cNvPr>
           <p:cNvPicPr>
             <a:picLocks noChangeAspect="1"/>
           </p:cNvPicPr>
@@ -11347,7 +12244,7 @@
       </p:pic>
       <p:sp>
         <p:nvSpPr>
-          <p:cNvPr id="10" name="chip-158"/>
+          <p:cNvPr id="10" name="chip-189"/>
           <p:cNvSpPr/>
           <p:nvPr/>
         </p:nvSpPr>
@@ -11371,7 +12268,7 @@
       </p:sp>
       <p:sp>
         <p:nvSpPr>
-          <p:cNvPr id="11" name="chip-text-159"/>
+          <p:cNvPr id="11" name="chip-text-190"/>
           <p:cNvSpPr txBox="1"/>
           <p:nvPr/>
         </p:nvSpPr>
@@ -11410,7 +12307,7 @@
       </p:sp>
       <p:sp>
         <p:nvSpPr>
-          <p:cNvPr id="12" name="num-160"/>
+          <p:cNvPr id="12" name="num-191"/>
           <p:cNvSpPr/>
           <p:nvPr/>
         </p:nvSpPr>
@@ -11430,7 +12327,7 @@
       </p:sp>
       <p:sp>
         <p:nvSpPr>
-          <p:cNvPr id="13" name="num-text-161"/>
+          <p:cNvPr id="13" name="num-text-192"/>
           <p:cNvSpPr txBox="1"/>
           <p:nvPr/>
         </p:nvSpPr>
@@ -11469,7 +12366,7 @@
       </p:sp>
       <p:sp>
         <p:nvSpPr>
-          <p:cNvPr id="14" name="text-162"/>
+          <p:cNvPr id="14" name="text-193"/>
           <p:cNvSpPr txBox="1"/>
           <p:nvPr/>
         </p:nvSpPr>
@@ -11508,7 +12405,7 @@
       </p:sp>
       <p:sp>
         <p:nvSpPr>
-          <p:cNvPr id="15" name="text-163"/>
+          <p:cNvPr id="15" name="text-194"/>
           <p:cNvSpPr txBox="1"/>
           <p:nvPr/>
         </p:nvSpPr>
@@ -11547,7 +12444,7 @@
       </p:sp>
       <p:sp>
         <p:nvSpPr>
-          <p:cNvPr id="16" name="shot-frame-164"/>
+          <p:cNvPr id="16" name="shot-frame-195"/>
           <p:cNvSpPr/>
           <p:nvPr/>
         </p:nvSpPr>
@@ -11576,7 +12473,7 @@
       </p:sp>
       <p:pic>
         <p:nvPicPr>
-          <p:cNvPr id="17" name="screenshot-165" descr="Təsdiq axınının qurulması: xərc mərkəzi sahibi, divizion rəhbəri, maliyyə yoxlaması, CFO, şərti CEO mərhələsi">    </p:cNvPr>
+          <p:cNvPr id="17" name="screenshot-196" descr="Təsdiq axınının qurulması: xərc mərkəzi sahibi, divizion rəhbəri, maliyyə yoxlaması, CFO, şərti CEO mərhələsi">    </p:cNvPr>
           <p:cNvPicPr>
             <a:picLocks noChangeAspect="1"/>
           </p:cNvPicPr>
@@ -11600,7 +12497,7 @@
       </p:pic>
       <p:sp>
         <p:nvSpPr>
-          <p:cNvPr id="18" name="num-166"/>
+          <p:cNvPr id="18" name="num-197"/>
           <p:cNvSpPr/>
           <p:nvPr/>
         </p:nvSpPr>
@@ -11620,7 +12517,7 @@
       </p:sp>
       <p:sp>
         <p:nvSpPr>
-          <p:cNvPr id="19" name="num-text-167"/>
+          <p:cNvPr id="19" name="num-text-198"/>
           <p:cNvSpPr txBox="1"/>
           <p:nvPr/>
         </p:nvSpPr>
@@ -11659,7 +12556,7 @@
       </p:sp>
       <p:sp>
         <p:nvSpPr>
-          <p:cNvPr id="20" name="text-168"/>
+          <p:cNvPr id="20" name="text-199"/>
           <p:cNvSpPr txBox="1"/>
           <p:nvPr/>
         </p:nvSpPr>
@@ -11698,7 +12595,7 @@
       </p:sp>
       <p:sp>
         <p:nvSpPr>
-          <p:cNvPr id="21" name="text-169"/>
+          <p:cNvPr id="21" name="text-200"/>
           <p:cNvSpPr txBox="1"/>
           <p:nvPr/>
         </p:nvSpPr>
@@ -11737,7 +12634,7 @@
       </p:sp>
       <p:sp>
         <p:nvSpPr>
-          <p:cNvPr id="22" name="shot-frame-170"/>
+          <p:cNvPr id="22" name="shot-frame-201"/>
           <p:cNvSpPr/>
           <p:nvPr/>
         </p:nvSpPr>
@@ -11766,7 +12663,7 @@
       </p:sp>
       <p:pic>
         <p:nvPicPr>
-          <p:cNvPr id="23" name="screenshot-171" descr="İdarəetmə paneli: illik büdcə, dövr üzrə büdcə, fakt, açıq öhdəliklər, qalıq">    </p:cNvPr>
+          <p:cNvPr id="23" name="screenshot-202" descr="İdarəetmə paneli: illik büdcə, dövr üzrə büdcə, fakt, açıq öhdəliklər, qalıq">    </p:cNvPr>
           <p:cNvPicPr>
             <a:picLocks noChangeAspect="1"/>
           </p:cNvPicPr>
@@ -11863,7 +12760,7 @@
       </p:grpSpPr>
       <p:sp>
         <p:nvSpPr>
-          <p:cNvPr id="2" name="kicker-172"/>
+          <p:cNvPr id="2" name="kicker-203"/>
           <p:cNvSpPr txBox="1"/>
           <p:nvPr/>
         </p:nvSpPr>
@@ -11943,7 +12840,7 @@
       </p:sp>
       <p:sp>
         <p:nvSpPr>
-          <p:cNvPr id="4" name="gtm-steps-173"/>
+          <p:cNvPr id="4" name="gtm-steps-204"/>
           <p:cNvSpPr/>
           <p:nvPr/>
         </p:nvSpPr>
@@ -11995,7 +12892,7 @@
       </p:sp>
       <p:sp>
         <p:nvSpPr>
-          <p:cNvPr id="6" name="num-174"/>
+          <p:cNvPr id="6" name="num-205"/>
           <p:cNvSpPr/>
           <p:nvPr/>
         </p:nvSpPr>
@@ -12015,7 +12912,7 @@
       </p:sp>
       <p:sp>
         <p:nvSpPr>
-          <p:cNvPr id="7" name="num-text-175"/>
+          <p:cNvPr id="7" name="num-text-206"/>
           <p:cNvSpPr txBox="1"/>
           <p:nvPr/>
         </p:nvSpPr>
@@ -12054,7 +12951,7 @@
       </p:sp>
       <p:sp>
         <p:nvSpPr>
-          <p:cNvPr id="8" name="text-176"/>
+          <p:cNvPr id="8" name="text-207"/>
           <p:cNvSpPr txBox="1"/>
           <p:nvPr/>
         </p:nvSpPr>
@@ -12093,7 +12990,7 @@
       </p:sp>
       <p:sp>
         <p:nvSpPr>
-          <p:cNvPr id="9" name="text-177"/>
+          <p:cNvPr id="9" name="text-208"/>
           <p:cNvSpPr txBox="1"/>
           <p:nvPr/>
         </p:nvSpPr>
@@ -12132,7 +13029,7 @@
       </p:sp>
       <p:sp>
         <p:nvSpPr>
-          <p:cNvPr id="10" name="num-178"/>
+          <p:cNvPr id="10" name="num-209"/>
           <p:cNvSpPr/>
           <p:nvPr/>
         </p:nvSpPr>
@@ -12152,7 +13049,7 @@
       </p:sp>
       <p:sp>
         <p:nvSpPr>
-          <p:cNvPr id="11" name="num-text-179"/>
+          <p:cNvPr id="11" name="num-text-210"/>
           <p:cNvSpPr txBox="1"/>
           <p:nvPr/>
         </p:nvSpPr>
@@ -12191,7 +13088,7 @@
       </p:sp>
       <p:sp>
         <p:nvSpPr>
-          <p:cNvPr id="12" name="text-180"/>
+          <p:cNvPr id="12" name="text-211"/>
           <p:cNvSpPr txBox="1"/>
           <p:nvPr/>
         </p:nvSpPr>
@@ -12230,7 +13127,7 @@
       </p:sp>
       <p:sp>
         <p:nvSpPr>
-          <p:cNvPr id="13" name="text-181"/>
+          <p:cNvPr id="13" name="text-212"/>
           <p:cNvSpPr txBox="1"/>
           <p:nvPr/>
         </p:nvSpPr>
@@ -12269,7 +13166,7 @@
       </p:sp>
       <p:sp>
         <p:nvSpPr>
-          <p:cNvPr id="14" name="num-182"/>
+          <p:cNvPr id="14" name="num-213"/>
           <p:cNvSpPr/>
           <p:nvPr/>
         </p:nvSpPr>
@@ -12289,7 +13186,7 @@
       </p:sp>
       <p:sp>
         <p:nvSpPr>
-          <p:cNvPr id="15" name="num-text-183"/>
+          <p:cNvPr id="15" name="num-text-214"/>
           <p:cNvSpPr txBox="1"/>
           <p:nvPr/>
         </p:nvSpPr>
@@ -12328,7 +13225,7 @@
       </p:sp>
       <p:sp>
         <p:nvSpPr>
-          <p:cNvPr id="16" name="text-184"/>
+          <p:cNvPr id="16" name="text-215"/>
           <p:cNvSpPr txBox="1"/>
           <p:nvPr/>
         </p:nvSpPr>
@@ -12367,7 +13264,7 @@
       </p:sp>
       <p:sp>
         <p:nvSpPr>
-          <p:cNvPr id="17" name="text-185"/>
+          <p:cNvPr id="17" name="text-216"/>
           <p:cNvSpPr txBox="1"/>
           <p:nvPr/>
         </p:nvSpPr>
@@ -12406,7 +13303,7 @@
       </p:sp>
       <p:sp>
         <p:nvSpPr>
-          <p:cNvPr id="18" name="num-186"/>
+          <p:cNvPr id="18" name="num-217"/>
           <p:cNvSpPr/>
           <p:nvPr/>
         </p:nvSpPr>
@@ -12426,7 +13323,7 @@
       </p:sp>
       <p:sp>
         <p:nvSpPr>
-          <p:cNvPr id="19" name="num-text-187"/>
+          <p:cNvPr id="19" name="num-text-218"/>
           <p:cNvSpPr txBox="1"/>
           <p:nvPr/>
         </p:nvSpPr>
@@ -12465,7 +13362,7 @@
       </p:sp>
       <p:sp>
         <p:nvSpPr>
-          <p:cNvPr id="20" name="text-188"/>
+          <p:cNvPr id="20" name="text-219"/>
           <p:cNvSpPr txBox="1"/>
           <p:nvPr/>
         </p:nvSpPr>
@@ -12504,7 +13401,7 @@
       </p:sp>
       <p:sp>
         <p:nvSpPr>
-          <p:cNvPr id="21" name="text-189"/>
+          <p:cNvPr id="21" name="text-220"/>
           <p:cNvSpPr txBox="1"/>
           <p:nvPr/>
         </p:nvSpPr>
@@ -12543,7 +13440,7 @@
       </p:sp>
       <p:sp>
         <p:nvSpPr>
-          <p:cNvPr id="22" name="num-190"/>
+          <p:cNvPr id="22" name="num-221"/>
           <p:cNvSpPr/>
           <p:nvPr/>
         </p:nvSpPr>
@@ -12563,7 +13460,7 @@
       </p:sp>
       <p:sp>
         <p:nvSpPr>
-          <p:cNvPr id="23" name="num-text-191"/>
+          <p:cNvPr id="23" name="num-text-222"/>
           <p:cNvSpPr txBox="1"/>
           <p:nvPr/>
         </p:nvSpPr>
@@ -12602,7 +13499,7 @@
       </p:sp>
       <p:sp>
         <p:nvSpPr>
-          <p:cNvPr id="24" name="text-192"/>
+          <p:cNvPr id="24" name="text-223"/>
           <p:cNvSpPr txBox="1"/>
           <p:nvPr/>
         </p:nvSpPr>
@@ -12641,7 +13538,7 @@
       </p:sp>
       <p:sp>
         <p:nvSpPr>
-          <p:cNvPr id="25" name="text-193"/>
+          <p:cNvPr id="25" name="text-224"/>
           <p:cNvSpPr txBox="1"/>
           <p:nvPr/>
         </p:nvSpPr>
@@ -12680,7 +13577,7 @@
       </p:sp>
       <p:sp>
         <p:nvSpPr>
-          <p:cNvPr id="26" name="gtm-box-194"/>
+          <p:cNvPr id="26" name="gtm-box-225"/>
           <p:cNvSpPr/>
           <p:nvPr/>
         </p:nvSpPr>
@@ -12709,7 +13606,7 @@
       </p:sp>
       <p:sp>
         <p:nvSpPr>
-          <p:cNvPr id="27" name="icon-bg-195"/>
+          <p:cNvPr id="27" name="icon-bg-226"/>
           <p:cNvSpPr/>
           <p:nvPr/>
         </p:nvSpPr>
@@ -12731,7 +13628,7 @@
       </p:sp>
       <p:pic>
         <p:nvPicPr>
-          <p:cNvPr id="28" name="icon-LuTarget-196" descr="Target">    </p:cNvPr>
+          <p:cNvPr id="28" name="icon-LuTarget-227" descr="Target">    </p:cNvPr>
           <p:cNvPicPr>
             <a:picLocks noChangeAspect="1"/>
           </p:cNvPicPr>
@@ -12755,7 +13652,7 @@
       </p:pic>
       <p:sp>
         <p:nvSpPr>
-          <p:cNvPr id="29" name="text-197"/>
+          <p:cNvPr id="29" name="text-228"/>
           <p:cNvSpPr txBox="1"/>
           <p:nvPr/>
         </p:nvSpPr>
@@ -12794,7 +13691,7 @@
       </p:sp>
       <p:sp>
         <p:nvSpPr>
-          <p:cNvPr id="30" name="text-198"/>
+          <p:cNvPr id="30" name="text-229"/>
           <p:cNvSpPr txBox="1"/>
           <p:nvPr/>
         </p:nvSpPr>
@@ -12825,7 +13722,7 @@
                   <a:schemeClr val="tx1"/>
                 </a:solidFill>
               </a:rPr>
-              <a:t>Müsahibə etdiyimiz 6 şirkət — test mühitinə ilk dəvət hədəfləri</a:t>
+              <a:t>Müsahibə etdiyimiz 10 şirkət — test mühitinə ilk dəvət hədəfləri</a:t>
             </a:r>
             <a:endParaRPr lang="en-US" sz="1150" dirty="0"/>
           </a:p>
@@ -12833,7 +13730,7 @@
       </p:sp>
       <p:sp>
         <p:nvSpPr>
-          <p:cNvPr id="31" name="text-199"/>
+          <p:cNvPr id="31" name="text-230"/>
           <p:cNvSpPr txBox="1"/>
           <p:nvPr/>
         </p:nvSpPr>
@@ -12872,7 +13769,7 @@
       </p:sp>
       <p:sp>
         <p:nvSpPr>
-          <p:cNvPr id="32" name="gtm-box-200"/>
+          <p:cNvPr id="32" name="gtm-box-231"/>
           <p:cNvSpPr/>
           <p:nvPr/>
         </p:nvSpPr>
@@ -12901,7 +13798,7 @@
       </p:sp>
       <p:sp>
         <p:nvSpPr>
-          <p:cNvPr id="33" name="icon-bg-201"/>
+          <p:cNvPr id="33" name="icon-bg-232"/>
           <p:cNvSpPr/>
           <p:nvPr/>
         </p:nvSpPr>
@@ -12923,7 +13820,7 @@
       </p:sp>
       <p:pic>
         <p:nvPicPr>
-          <p:cNvPr id="34" name="icon-LuCalendarClock-202" descr="CalendarClock">    </p:cNvPr>
+          <p:cNvPr id="34" name="icon-LuCalendarClock-233" descr="CalendarClock">    </p:cNvPr>
           <p:cNvPicPr>
             <a:picLocks noChangeAspect="1"/>
           </p:cNvPicPr>
@@ -12947,7 +13844,7 @@
       </p:pic>
       <p:sp>
         <p:nvSpPr>
-          <p:cNvPr id="35" name="text-203"/>
+          <p:cNvPr id="35" name="text-234"/>
           <p:cNvSpPr txBox="1"/>
           <p:nvPr/>
         </p:nvSpPr>
@@ -12986,7 +13883,7 @@
       </p:sp>
       <p:sp>
         <p:nvSpPr>
-          <p:cNvPr id="36" name="text-204"/>
+          <p:cNvPr id="36" name="text-235"/>
           <p:cNvSpPr txBox="1"/>
           <p:nvPr/>
         </p:nvSpPr>
@@ -13025,7 +13922,7 @@
       </p:sp>
       <p:sp>
         <p:nvSpPr>
-          <p:cNvPr id="37" name="metrics-205"/>
+          <p:cNvPr id="37" name="metrics-236"/>
           <p:cNvSpPr/>
           <p:nvPr/>
         </p:nvSpPr>
@@ -13054,7 +13951,7 @@
       </p:sp>
       <p:sp>
         <p:nvSpPr>
-          <p:cNvPr id="38" name="icon-bg-206"/>
+          <p:cNvPr id="38" name="icon-bg-237"/>
           <p:cNvSpPr/>
           <p:nvPr/>
         </p:nvSpPr>
@@ -13076,7 +13973,7 @@
       </p:sp>
       <p:pic>
         <p:nvPicPr>
-          <p:cNvPr id="39" name="icon-LuGauge-207" descr="Gauge">    </p:cNvPr>
+          <p:cNvPr id="39" name="icon-LuGauge-238" descr="Gauge">    </p:cNvPr>
           <p:cNvPicPr>
             <a:picLocks noChangeAspect="1"/>
           </p:cNvPicPr>
@@ -13100,7 +13997,7 @@
       </p:pic>
       <p:sp>
         <p:nvSpPr>
-          <p:cNvPr id="40" name="text-208"/>
+          <p:cNvPr id="40" name="text-239"/>
           <p:cNvSpPr txBox="1"/>
           <p:nvPr/>
         </p:nvSpPr>
@@ -13139,7 +14036,7 @@
       </p:sp>
       <p:sp>
         <p:nvSpPr>
-          <p:cNvPr id="41" name="text-209"/>
+          <p:cNvPr id="41" name="text-240"/>
           <p:cNvSpPr txBox="1"/>
           <p:nvPr/>
         </p:nvSpPr>
@@ -13178,7 +14075,7 @@
       </p:sp>
       <p:sp>
         <p:nvSpPr>
-          <p:cNvPr id="42" name="dot-210"/>
+          <p:cNvPr id="42" name="dot-241"/>
           <p:cNvSpPr/>
           <p:nvPr/>
         </p:nvSpPr>
@@ -13198,7 +14095,7 @@
       </p:sp>
       <p:sp>
         <p:nvSpPr>
-          <p:cNvPr id="43" name="text-211"/>
+          <p:cNvPr id="43" name="text-242"/>
           <p:cNvSpPr txBox="1"/>
           <p:nvPr/>
         </p:nvSpPr>
@@ -13237,7 +14134,7 @@
       </p:sp>
       <p:sp>
         <p:nvSpPr>
-          <p:cNvPr id="44" name="dot-212"/>
+          <p:cNvPr id="44" name="dot-243"/>
           <p:cNvSpPr/>
           <p:nvPr/>
         </p:nvSpPr>
@@ -13257,7 +14154,7 @@
       </p:sp>
       <p:sp>
         <p:nvSpPr>
-          <p:cNvPr id="45" name="text-213"/>
+          <p:cNvPr id="45" name="text-244"/>
           <p:cNvSpPr txBox="1"/>
           <p:nvPr/>
         </p:nvSpPr>
@@ -13296,7 +14193,7 @@
       </p:sp>
       <p:sp>
         <p:nvSpPr>
-          <p:cNvPr id="46" name="dot-214"/>
+          <p:cNvPr id="46" name="dot-245"/>
           <p:cNvSpPr/>
           <p:nvPr/>
         </p:nvSpPr>
@@ -13316,7 +14213,7 @@
       </p:sp>
       <p:sp>
         <p:nvSpPr>
-          <p:cNvPr id="47" name="text-215"/>
+          <p:cNvPr id="47" name="text-246"/>
           <p:cNvSpPr txBox="1"/>
           <p:nvPr/>
         </p:nvSpPr>
@@ -13355,7 +14252,7 @@
       </p:sp>
       <p:sp>
         <p:nvSpPr>
-          <p:cNvPr id="48" name="dot-216"/>
+          <p:cNvPr id="48" name="dot-247"/>
           <p:cNvSpPr/>
           <p:nvPr/>
         </p:nvSpPr>
@@ -13375,7 +14272,7 @@
       </p:sp>
       <p:sp>
         <p:nvSpPr>
-          <p:cNvPr id="49" name="text-217"/>
+          <p:cNvPr id="49" name="text-248"/>
           <p:cNvSpPr txBox="1"/>
           <p:nvPr/>
         </p:nvSpPr>
@@ -13414,7 +14311,7 @@
       </p:sp>
       <p:sp>
         <p:nvSpPr>
-          <p:cNvPr id="50" name="dot-218"/>
+          <p:cNvPr id="50" name="dot-249"/>
           <p:cNvSpPr/>
           <p:nvPr/>
         </p:nvSpPr>
@@ -13434,7 +14331,7 @@
       </p:sp>
       <p:sp>
         <p:nvSpPr>
-          <p:cNvPr id="51" name="text-219"/>
+          <p:cNvPr id="51" name="text-250"/>
           <p:cNvSpPr txBox="1"/>
           <p:nvPr/>
         </p:nvSpPr>
@@ -13473,7 +14370,7 @@
       </p:sp>
       <p:sp>
         <p:nvSpPr>
-          <p:cNvPr id="52" name="dot-220"/>
+          <p:cNvPr id="52" name="dot-251"/>
           <p:cNvSpPr/>
           <p:nvPr/>
         </p:nvSpPr>
@@ -13493,7 +14390,7 @@
       </p:sp>
       <p:sp>
         <p:nvSpPr>
-          <p:cNvPr id="53" name="text-221"/>
+          <p:cNvPr id="53" name="text-252"/>
           <p:cNvSpPr txBox="1"/>
           <p:nvPr/>
         </p:nvSpPr>
@@ -13711,7 +14608,7 @@
       </p:sp>
       <p:sp>
         <p:nvSpPr>
-          <p:cNvPr id="5" name="text-222"/>
+          <p:cNvPr id="5" name="text-253"/>
           <p:cNvSpPr txBox="1"/>
           <p:nvPr/>
         </p:nvSpPr>
@@ -13750,7 +14647,7 @@
       </p:sp>
       <p:sp>
         <p:nvSpPr>
-          <p:cNvPr id="6" name="next-steps-223"/>
+          <p:cNvPr id="6" name="next-steps-254"/>
           <p:cNvSpPr/>
           <p:nvPr/>
         </p:nvSpPr>
@@ -13779,7 +14676,7 @@
       </p:sp>
       <p:sp>
         <p:nvSpPr>
-          <p:cNvPr id="7" name="text-224"/>
+          <p:cNvPr id="7" name="text-255"/>
           <p:cNvSpPr txBox="1"/>
           <p:nvPr/>
         </p:nvSpPr>
@@ -13821,7 +14718,7 @@
       </p:sp>
       <p:sp>
         <p:nvSpPr>
-          <p:cNvPr id="8" name="num-225"/>
+          <p:cNvPr id="8" name="num-256"/>
           <p:cNvSpPr/>
           <p:nvPr/>
         </p:nvSpPr>
@@ -13841,7 +14738,7 @@
       </p:sp>
       <p:sp>
         <p:nvSpPr>
-          <p:cNvPr id="9" name="num-text-226"/>
+          <p:cNvPr id="9" name="num-text-257"/>
           <p:cNvSpPr txBox="1"/>
           <p:nvPr/>
         </p:nvSpPr>
@@ -13880,7 +14777,7 @@
       </p:sp>
       <p:sp>
         <p:nvSpPr>
-          <p:cNvPr id="10" name="text-227"/>
+          <p:cNvPr id="10" name="text-258"/>
           <p:cNvSpPr txBox="1"/>
           <p:nvPr/>
         </p:nvSpPr>
@@ -13911,7 +14808,7 @@
                   <a:schemeClr val="tx1"/>
                 </a:solidFill>
               </a:rPr>
-              <a:t>6 şirkətə demo və test mühiti</a:t>
+              <a:t>10 şirkətə demo və test mühiti</a:t>
             </a:r>
             <a:endParaRPr lang="en-US" sz="1250" dirty="0"/>
           </a:p>
@@ -13919,7 +14816,7 @@
       </p:sp>
       <p:sp>
         <p:nvSpPr>
-          <p:cNvPr id="11" name="num-228"/>
+          <p:cNvPr id="11" name="num-259"/>
           <p:cNvSpPr/>
           <p:nvPr/>
         </p:nvSpPr>
@@ -13939,7 +14836,7 @@
       </p:sp>
       <p:sp>
         <p:nvSpPr>
-          <p:cNvPr id="12" name="num-text-229"/>
+          <p:cNvPr id="12" name="num-text-260"/>
           <p:cNvSpPr txBox="1"/>
           <p:nvPr/>
         </p:nvSpPr>
@@ -13978,7 +14875,7 @@
       </p:sp>
       <p:sp>
         <p:nvSpPr>
-          <p:cNvPr id="13" name="text-230"/>
+          <p:cNvPr id="13" name="text-261"/>
           <p:cNvSpPr txBox="1"/>
           <p:nvPr/>
         </p:nvSpPr>
@@ -14017,7 +14914,7 @@
       </p:sp>
       <p:sp>
         <p:nvSpPr>
-          <p:cNvPr id="14" name="num-231"/>
+          <p:cNvPr id="14" name="num-262"/>
           <p:cNvSpPr/>
           <p:nvPr/>
         </p:nvSpPr>
@@ -14037,7 +14934,7 @@
       </p:sp>
       <p:sp>
         <p:nvSpPr>
-          <p:cNvPr id="15" name="num-text-232"/>
+          <p:cNvPr id="15" name="num-text-263"/>
           <p:cNvSpPr txBox="1"/>
           <p:nvPr/>
         </p:nvSpPr>
@@ -14076,7 +14973,7 @@
       </p:sp>
       <p:sp>
         <p:nvSpPr>
-          <p:cNvPr id="16" name="text-233"/>
+          <p:cNvPr id="16" name="text-264"/>
           <p:cNvSpPr txBox="1"/>
           <p:nvPr/>
         </p:nvSpPr>
@@ -14138,7 +15035,7 @@
       </p:sp>
       <p:sp>
         <p:nvSpPr>
-          <p:cNvPr id="18" name="text-234"/>
+          <p:cNvPr id="18" name="text-265"/>
           <p:cNvSpPr txBox="1"/>
           <p:nvPr/>
         </p:nvSpPr>
@@ -14177,7 +15074,7 @@
       </p:sp>
       <p:sp>
         <p:nvSpPr>
-          <p:cNvPr id="19" name="text-235"/>
+          <p:cNvPr id="19" name="text-266"/>
           <p:cNvSpPr txBox="1"/>
           <p:nvPr/>
         </p:nvSpPr>
@@ -14216,7 +15113,7 @@
       </p:sp>
       <p:sp>
         <p:nvSpPr>
-          <p:cNvPr id="20" name="text-236"/>
+          <p:cNvPr id="20" name="text-267"/>
           <p:cNvSpPr txBox="1"/>
           <p:nvPr/>
         </p:nvSpPr>

</xml_diff>